<commit_message>
refactor(slides): Rediseño completo a estilo Corporativo / Business / Gubernamental limpio (White/Navy)
</commit_message>
<xml_diff>
--- a/PRESENTACION_EJECUTIVA_MIGATO_V3.pptx
+++ b/PRESENTACION_EJECUTIVA_MIGATO_V3.pptx
@@ -511,7 +511,7 @@
           <a:lstStyle/>
           <a:p>
             <a:r>
-              <a:t>GUION: Saludos cordiales a la Dirección de MIGATO. Hoy venimos a presentar la solución tecnológica definitiva para coordinar las 44 parroquias de Monagas y resguardar el voto. Todo el software ya fue desarrollado por nuestro equipo sin costo de honorarios; el único objetivo de hoy es aprobar un presupuesto mínimo de $24.50 al mes para el servidor cloud.</a:t>
+              <a:t>GUION: Estimados miembros de la Dirección General: les presentamos el dictamen técnico y la propuesta de factibilidad para la puesta en marcha de la Plataforma Territorial MIGATO. El desarrollo del software ha sido completado al 100% por nuestro equipo sin costo de honorarios para la organización. El objetivo de esta sesión ejecutiva es someter a su consideración la aprobación de un presupuesto operativo mínimo de $24.50 mensuales para la infraestructura cloud del servidor privado.</a:t>
             </a:r>
           </a:p>
         </p:txBody>
@@ -581,7 +581,7 @@
           <a:lstStyle/>
           <a:p>
             <a:r>
-              <a:t>GUION: Para cerrar: la herramienta está lista. No hay que esperar meses de desarrollo. Si la dirección aprueba hoy los 294 dólares, en 48 horas tenemos el servidor arriba y los coordinadores probando en Las Cocuizas, San Simón y Los Godos. Quedamos a su disposición para cualquier pregunta técnica.</a:t>
+              <a:t>GUION: Para concluir, reiteramos que la herramienta se encuentra completamente terminada, probada y lista para entrar en operación. Ofrece una alta solvencia funcional y un protocolo estricto de resguardo para la militancia. Con una inversión mínima de 294 dólares anuales, MIGATO se dota de una plataforma corporativa soberana. El Equipo Técnico recomienda formalmente la aprobación de este presupuesto para iniciar el encendido de inmediato. Quedamos a su disposición.</a:t>
             </a:r>
           </a:p>
         </p:txBody>
@@ -651,7 +651,7 @@
           <a:lstStyle/>
           <a:p>
             <a:r>
-              <a:t>GUION: Compañeros, la gestión pública actual fracasó por falta de método y exceso de politiquería. Nosotros proponemos orden gerencial y competencia técnica. No podemos seguir organizando elecciones ni levantando censos por WhatsApp. Necesitamos un sistema profesional que proteja a nuestra gente.</a:t>
+              <a:t>GUION: La gestión pública en Monagas enfrenta una severa ineficiencia burocrática que ha deteriorado los servicios básicos y la confianza ciudadana. En el ámbito organizativo, operar mediante canales informales de mensajería genera dispersión, pérdida de datos y riesgos de seguridad para los equipos de campo. Frente a este panorama, MIGATO propone un modelo de gestión basado en la competencia técnica, la transparencia administrativa y la toma de decisiones fundamentada en indicadores reales y auditables.</a:t>
             </a:r>
           </a:p>
         </p:txBody>
@@ -721,7 +721,7 @@
           <a:lstStyle/>
           <a:p>
             <a:r>
-              <a:t>GUION: Esta plataforma no es un concepto en papel: ya está programada. Cubre las 5 áreas neurálgicas: despacho de enlaces, censo vecinal, defensa electoral, mapa estratégico 3D y auditoría de hospitales. Todo integrado en un solo entorno web.</a:t>
+              <a:t>GUION: La plataforma constituye una solución tecnológica completa y operativa que articula cinco componentes complementarios: despacho parroquial por enlace web seguro, censo comunitario con resguardo de privacidad, seguimiento del padrón electoral con archivo de actas, consola cartográfica 3D y supervisión técnica de la red regional de salud. Todo el sistema opera bajo una arquitectura web unificada, accesible y sin intermediarios.</a:t>
             </a:r>
           </a:p>
         </p:txBody>
@@ -791,7 +791,7 @@
           <a:lstStyle/>
           <a:p>
             <a:r>
-              <a:t>GUION: El mayor temor de nuestra gente en la calle es que les revisen el teléfono. Diseñamos la plataforma con seguridad por defecto: el coordinador entra con un solo clic y, al llenar el censo, en su celular queda CERO información. Si le revisan el teléfono, no hay absolutamente nada.</a:t>
+              <a:t>GUION: En el trabajo de campo, la seguridad de nuestros coordinadores y la privacidad ciudadana son prioritarias. Por ello, el Módulo 1 elimina contraseñas mediante tokens seguros que dan acceso exclusivo a la parroquia asignada. En el Módulo 2, el censo se enfoca en necesidades cuantitativas (familias, viviendas, transformadores) y, por principio ético, no recopila nombres ni cédulas. Al enviar el formulario, los datos viajan cifrados y el teléfono queda completamente limpio.</a:t>
             </a:r>
           </a:p>
         </p:txBody>
@@ -861,7 +861,7 @@
           <a:lstStyle/>
           <a:p>
             <a:r>
-              <a:t>GUION: El Módulo 3 no es un intermediario del CNE ni promete milagros: es una herramienta de control interno del partido. Tenemos georreferenciados los 175 centros de Maturín. Nuestros testigos suben la foto del acta con su código QR para tener nuestro propio respaldo auditable y blindado.</a:t>
+              <a:t>GUION: El Módulo 3 está concebido como una herramienta de archivo y auditoría interna para la organización, respetando plenamente el marco institucional. Mapea la totalidad de los 175 centros y 361 mesas de Maturín, identificando los 40 centros que concentran más del 60% del padrón. Facilita la asignación de testigos y permite cargar los resultados con respaldo fotográfico del acta física y comprobante impreso con su código QR, asegurando un expediente fehaciente para nuestro cotejo interno.</a:t>
             </a:r>
           </a:p>
         </p:txBody>
@@ -931,7 +931,7 @@
           <a:lstStyle/>
           <a:p>
             <a:r>
-              <a:t>GUION: El Módulo 4 nos da visión tridimensional para planificar logística sin perdernos en el mapa. Y el Módulo 5 de Salud es nuestra mejor bandera: 84 centros diagnosticados. Le mostramos a Monagas exactamente qué falla y cómo lo vamos a solucionar con datos en la mano.</a:t>
+              <a:t>GUION: El Módulo 4 ofrece a la Dirección una consola geoespacial tridimensional para evaluar la topografía, la red de carreteras y los servicios públicos. Incorpora un filtro de focalización territorial que atenúa las áreas circundantes para centrar el debate ejecutivo en la parroquia evaluada. Por su parte, el Módulo 5 audita técnicamente 84 centros de salud de Monagas, registrando el estado de plantas eléctricas y quirófanos, lo que provee el fundamento técnico indispensable para nuestras propuestas de gobierno.</a:t>
             </a:r>
           </a:p>
         </p:txBody>
@@ -1001,7 +1001,7 @@
           <a:lstStyle/>
           <a:p>
             <a:r>
-              <a:t>GUION: Una plataforma de este calibre no puede vivir en un hosting gratuito ni en servidores compartidos baratos donde te suspenden la cuenta sin aviso. Necesitamos un VPS privado dedicado con cifrado de 256 bits y pruebas de estrés para que jamás se caiga.</a:t>
+              <a:t>GUION: Una solución estratégica de esta magnitud requiere una infraestructura profesional. A diferencia de los alojamientos compartidos que sufren caídas imprevistas y carecen de aislamiento, un Servidor Virtual Privado dedicado nos otorga independencia, procesamiento exclusivo y respaldo continuo. Implementamos cifrado SSL de 256 bits, reglas de cortafuegos y pruebas de estrés para asegurar que la plataforma mantenga tiempos de respuesta inferiores a un segundo durante picos de concurrencia.</a:t>
             </a:r>
           </a:p>
         </p:txBody>
@@ -1071,7 +1071,7 @@
           <a:lstStyle/>
           <a:p>
             <a:r>
-              <a:t>GUION: Miren los números con total transparencia: son exactamente 294 dólares AL AÑO. No estamos cobrando un solo centavo por el desarrollo de la plataforma, que en el mercado corporativo costaría miles de dólares. Solo pedimos el costo directo de la nube: 24 dólares y medio al mes para encender el servidor.</a:t>
+              <a:t>GUION: En esta lámina presentamos el análisis económico con estricta transparencia. El costo del desarrollo de software y arquitectura representa cero bolívares y cero dólares para la organización, habiendo sido aportado íntegramente por el equipo técnico. La inversión solicitada se limita exclusivamente a los costos directos de la nube: $20 mensuales por el VPS dedicado, $1.50 por el dominio y certificados SSL, y $3 por la IP fija. El total asciende a 24 dólares y medio mensuales, o 294 dólares anuales.</a:t>
             </a:r>
           </a:p>
         </p:txBody>
@@ -1141,7 +1141,7 @@
           <a:lstStyle/>
           <a:p>
             <a:r>
-              <a:t>GUION: No venimos a pedir presupuestos gigantescos para computadoras o pantallas ahora mismo. Eso es la Fase 2. Hoy solo venimos por la Fase 1: los 294 dólares para encender el servidor y validar las 3 parroquias piloto más grandes de Maturín.</a:t>
+              <a:t>GUION: Con un criterio gerencial responsable, proponemos una implementación escalonada en dos etapas. La presente solicitud corresponde exclusivamente a la Fase 1, con una inversión única de 294 dólares anuales para encender el servidor y validar la plataforma en tres parroquias piloto de Maturín: Las Cocuizas, San Simón y Alto de Los Godos. La Fase 2, relativa al equipamiento físico de la Sala Situacional, se evaluará posteriormente según la disponibilidad y planificación del partido.</a:t>
             </a:r>
           </a:p>
         </p:txBody>
@@ -4162,7 +4162,7 @@
             <a:avLst/>
           </a:prstGeom>
           <a:solidFill>
-            <a:srgbClr val="0F172A"/>
+            <a:srgbClr val="F8FAFC"/>
           </a:solidFill>
           <a:ln>
             <a:noFill/>
@@ -4206,8 +4206,8 @@
         </p:blipFill>
         <p:spPr>
           <a:xfrm>
-            <a:off x="5303520" y="731520"/>
-            <a:ext cx="1645920" cy="1645920"/>
+            <a:off x="5394960" y="822960"/>
+            <a:ext cx="1371600" cy="1371600"/>
           </a:xfrm>
           <a:prstGeom prst="rect">
             <a:avLst/>
@@ -4222,8 +4222,8 @@
         </p:nvSpPr>
         <p:spPr>
           <a:xfrm>
-            <a:off x="914400" y="2560320"/>
-            <a:ext cx="10362895" cy="3657600"/>
+            <a:off x="914400" y="2377440"/>
+            <a:ext cx="10362895" cy="3840480"/>
           </a:xfrm>
           <a:prstGeom prst="rect">
             <a:avLst/>
@@ -4237,9 +4237,9 @@
           <a:lstStyle/>
           <a:p>
             <a:pPr algn="ctr">
-              <a:defRPr sz="1300" b="1">
-                <a:solidFill>
-                  <a:srgbClr val="38BDF8"/>
+              <a:defRPr sz="1200" b="1">
+                <a:solidFill>
+                  <a:srgbClr val="0284C7"/>
                 </a:solidFill>
                 <a:latin typeface="Arial"/>
               </a:defRPr>
@@ -4255,7 +4255,7 @@
               </a:spcAft>
               <a:defRPr sz="1500" b="1">
                 <a:solidFill>
-                  <a:srgbClr val="FFFFFF"/>
+                  <a:srgbClr val="1E3A8A"/>
                 </a:solidFill>
                 <a:latin typeface="Arial"/>
               </a:defRPr>
@@ -4269,48 +4269,48 @@
               <a:spcAft>
                 <a:spcPts val="1000"/>
               </a:spcAft>
-              <a:defRPr sz="2600" b="1">
-                <a:solidFill>
-                  <a:srgbClr val="FFFFFF"/>
-                </a:solidFill>
-                <a:latin typeface="Arial"/>
-              </a:defRPr>
-            </a:pPr>
-            <a:r>
-              <a:t>ARQUITECTURA DE GESTIÓN TERRITORIAL, SEGURIDAD</a:t>
-            </a:r>
-            <a:br/>
-            <a:r>
-              <a:t>Y PRESUPUESTO OPERATIVO DE SERVIDORES</a:t>
+              <a:defRPr sz="2400" b="1">
+                <a:solidFill>
+                  <a:srgbClr val="0F172A"/>
+                </a:solidFill>
+                <a:latin typeface="Arial"/>
+              </a:defRPr>
+            </a:pPr>
+            <a:r>
+              <a:t>ARQUITECTURA DE GESTIÓN TERRITORIAL Y PROPUESTA DE FACTIBILIDAD TÉCNICA</a:t>
             </a:r>
           </a:p>
           <a:p>
             <a:pPr algn="ctr">
               <a:spcAft>
-                <a:spcPts val="2000"/>
+                <a:spcPts val="2200"/>
               </a:spcAft>
-              <a:defRPr sz="1500" i="1">
-                <a:solidFill>
-                  <a:srgbClr val="E2E8F0"/>
-                </a:solidFill>
-                <a:latin typeface="Arial"/>
-              </a:defRPr>
-            </a:pPr>
-            <a:r>
-              <a:t>Propuesta de Factibilidad Técnica de los 5 Módulos y Servidor Cloud VPS Privado</a:t>
+              <a:defRPr sz="1400" i="1">
+                <a:solidFill>
+                  <a:srgbClr val="64748B"/>
+                </a:solidFill>
+                <a:latin typeface="Arial"/>
+              </a:defRPr>
+            </a:pPr>
+            <a:r>
+              <a:t>Evaluación Integral de los Cinco Módulos de Mando, Servidor Cloud VPS Privado y Presupuesto Operativo</a:t>
             </a:r>
           </a:p>
           <a:p>
             <a:pPr algn="ctr">
               <a:defRPr sz="1200">
                 <a:solidFill>
-                  <a:srgbClr val="94A3B8"/>
-                </a:solidFill>
-                <a:latin typeface="Arial"/>
-              </a:defRPr>
-            </a:pPr>
-            <a:r>
-              <a:t>Presentado por el Equipo Técnico de Sistemas y Arquitectura Digital • Maturín, Septiembre 2026</a:t>
+                  <a:srgbClr val="334155"/>
+                </a:solidFill>
+                <a:latin typeface="Arial"/>
+              </a:defRPr>
+            </a:pPr>
+            <a:r>
+              <a:t>Presentado por el Equipo Técnico de Sistemas y Arquitectura Digital</a:t>
+            </a:r>
+            <a:br/>
+            <a:r>
+              <a:t>A la Dirección General de MIGATO • Maturín, Septiembre 2026</a:t>
             </a:r>
           </a:p>
         </p:txBody>
@@ -4348,7 +4348,7 @@
             <a:avLst/>
           </a:prstGeom>
           <a:solidFill>
-            <a:srgbClr val="0F172A"/>
+            <a:srgbClr val="F8FAFC"/>
           </a:solidFill>
           <a:ln>
             <a:noFill/>
@@ -4385,7 +4385,7 @@
         <p:spPr>
           <a:xfrm>
             <a:off x="731520" y="365760"/>
-            <a:ext cx="9144000" cy="365760"/>
+            <a:ext cx="9144000" cy="320040"/>
           </a:xfrm>
           <a:prstGeom prst="rect">
             <a:avLst/>
@@ -4399,15 +4399,15 @@
           <a:lstStyle/>
           <a:p>
             <a:pPr>
-              <a:defRPr sz="1100" b="1">
-                <a:solidFill>
-                  <a:srgbClr val="38BDF8"/>
-                </a:solidFill>
-                <a:latin typeface="Arial"/>
-              </a:defRPr>
-            </a:pPr>
-            <a:r>
-              <a:t>MIGATO • EQUIPO TÉCNICO DE SISTEMAS</a:t>
+              <a:defRPr sz="1000" b="1">
+                <a:solidFill>
+                  <a:srgbClr val="0284C7"/>
+                </a:solidFill>
+                <a:latin typeface="Arial"/>
+              </a:defRPr>
+            </a:pPr>
+            <a:r>
+              <a:t>MIGATO • EQUIPO TÉCNICO DE SISTEMAS Y ARQUITECTURA DIGITAL</a:t>
             </a:r>
           </a:p>
         </p:txBody>
@@ -4420,8 +4420,8 @@
         </p:nvSpPr>
         <p:spPr>
           <a:xfrm>
-            <a:off x="731520" y="685800"/>
-            <a:ext cx="9601200" cy="731520"/>
+            <a:off x="731520" y="658368"/>
+            <a:ext cx="9601200" cy="685800"/>
           </a:xfrm>
           <a:prstGeom prst="rect">
             <a:avLst/>
@@ -4435,15 +4435,15 @@
           <a:lstStyle/>
           <a:p>
             <a:pPr>
-              <a:defRPr sz="2400" b="1">
-                <a:solidFill>
-                  <a:srgbClr val="FFFFFF"/>
-                </a:solidFill>
-                <a:latin typeface="Arial"/>
-              </a:defRPr>
-            </a:pPr>
-            <a:r>
-              <a:t>Conclusión y Dictamen Técnico: El Momento es Ahora</a:t>
+              <a:defRPr sz="2200" b="1">
+                <a:solidFill>
+                  <a:srgbClr val="0F172A"/>
+                </a:solidFill>
+                <a:latin typeface="Arial"/>
+              </a:defRPr>
+            </a:pPr>
+            <a:r>
+              <a:t>Conclusión y Recomendación Final del Equipo Técnico</a:t>
             </a:r>
           </a:p>
         </p:txBody>
@@ -4465,7 +4465,7 @@
         <p:spPr>
           <a:xfrm>
             <a:off x="10789920" y="365760"/>
-            <a:ext cx="731520" cy="731520"/>
+            <a:ext cx="685800" cy="685800"/>
           </a:xfrm>
           <a:prstGeom prst="rect">
             <a:avLst/>
@@ -4480,14 +4480,14 @@
         </p:nvSpPr>
         <p:spPr>
           <a:xfrm>
-            <a:off x="731520" y="1463040"/>
+            <a:off x="731520" y="1371600"/>
             <a:ext cx="10728655" cy="18288"/>
           </a:xfrm>
           <a:prstGeom prst="rect">
             <a:avLst/>
           </a:prstGeom>
           <a:solidFill>
-            <a:srgbClr val="334155"/>
+            <a:srgbClr val="1E3A8A"/>
           </a:solidFill>
           <a:ln>
             <a:noFill/>
@@ -4523,18 +4523,18 @@
         </p:nvSpPr>
         <p:spPr>
           <a:xfrm>
-            <a:off x="1371600" y="1737360"/>
-            <a:ext cx="9448495" cy="4389120"/>
+            <a:off x="1097280" y="1645920"/>
+            <a:ext cx="9997135" cy="4572000"/>
           </a:xfrm>
           <a:prstGeom prst="roundRect">
             <a:avLst/>
           </a:prstGeom>
           <a:solidFill>
-            <a:srgbClr val="1E293B"/>
+            <a:srgbClr val="FFFFFF"/>
           </a:solidFill>
           <a:ln>
             <a:solidFill>
-              <a:srgbClr val="0284C7"/>
+              <a:srgbClr val="1E3A8A"/>
             </a:solidFill>
           </a:ln>
         </p:spPr>
@@ -4568,8 +4568,8 @@
         </p:nvSpPr>
         <p:spPr>
           <a:xfrm>
-            <a:off x="1645920" y="1920240"/>
-            <a:ext cx="8899855" cy="4023360"/>
+            <a:off x="1371600" y="1828800"/>
+            <a:ext cx="9448495" cy="4114800"/>
           </a:xfrm>
           <a:prstGeom prst="rect">
             <a:avLst/>
@@ -4586,111 +4586,111 @@
               <a:spcAft>
                 <a:spcPts val="1400"/>
               </a:spcAft>
-              <a:defRPr sz="1800" b="1">
-                <a:solidFill>
-                  <a:srgbClr val="38BDF8"/>
-                </a:solidFill>
-                <a:latin typeface="Arial"/>
-              </a:defRPr>
-            </a:pPr>
-            <a:r>
-              <a:t>✅ Dictamen Favorable del Equipo Técnico</a:t>
+              <a:defRPr sz="1700" b="1">
+                <a:solidFill>
+                  <a:srgbClr val="1E3A8A"/>
+                </a:solidFill>
+                <a:latin typeface="Arial"/>
+              </a:defRPr>
+            </a:pPr>
+            <a:r>
+              <a:t>✅ Dictamen Favorable y Factibilidad Técnica</a:t>
             </a:r>
           </a:p>
           <a:p>
             <a:pPr>
               <a:spcAft>
-                <a:spcPts val="400"/>
+                <a:spcPts val="200"/>
               </a:spcAft>
-              <a:defRPr sz="1300" b="1">
-                <a:solidFill>
-                  <a:srgbClr val="FFFFFF"/>
-                </a:solidFill>
-                <a:latin typeface="Arial"/>
-              </a:defRPr>
-            </a:pPr>
-            <a:r>
-              <a:t>• Madurez del Software: </a:t>
+              <a:defRPr sz="1200" b="1">
+                <a:solidFill>
+                  <a:srgbClr val="0F172A"/>
+                </a:solidFill>
+                <a:latin typeface="Arial"/>
+              </a:defRPr>
+            </a:pPr>
+            <a:r>
+              <a:t>▪ Madurez Funcional Comprobada: </a:t>
             </a:r>
           </a:p>
           <a:p>
             <a:pPr>
               <a:spcAft>
-                <a:spcPts val="1000"/>
+                <a:spcPts val="800"/>
               </a:spcAft>
-              <a:defRPr sz="1200">
-                <a:solidFill>
-                  <a:srgbClr val="E2E8F0"/>
-                </a:solidFill>
-                <a:latin typeface="Arial"/>
-              </a:defRPr>
-            </a:pPr>
-            <a:r>
-              <a:t>   Los 5 módulos están programados, probados y listos para operar. No hay riesgo de desarrollo.</a:t>
+              <a:defRPr sz="1150">
+                <a:solidFill>
+                  <a:srgbClr val="334155"/>
+                </a:solidFill>
+                <a:latin typeface="Arial"/>
+              </a:defRPr>
+            </a:pPr>
+            <a:r>
+              <a:t>   Los cinco módulos se encuentran programados y evaluados en entornos de prueba, garantizando plena operatividad sin riesgos de desarrollo.</a:t>
             </a:r>
           </a:p>
           <a:p>
             <a:pPr>
               <a:spcAft>
-                <a:spcPts val="400"/>
+                <a:spcPts val="200"/>
               </a:spcAft>
-              <a:defRPr sz="1300" b="1">
-                <a:solidFill>
-                  <a:srgbClr val="FFFFFF"/>
-                </a:solidFill>
-                <a:latin typeface="Arial"/>
-              </a:defRPr>
-            </a:pPr>
-            <a:r>
-              <a:t>• Protección Total: </a:t>
+              <a:defRPr sz="1200" b="1">
+                <a:solidFill>
+                  <a:srgbClr val="0F172A"/>
+                </a:solidFill>
+                <a:latin typeface="Arial"/>
+              </a:defRPr>
+            </a:pPr>
+            <a:r>
+              <a:t>▪ Seguridad y Protección Institucional: </a:t>
             </a:r>
           </a:p>
           <a:p>
             <a:pPr>
               <a:spcAft>
-                <a:spcPts val="1000"/>
+                <a:spcPts val="800"/>
               </a:spcAft>
-              <a:defRPr sz="1200">
-                <a:solidFill>
-                  <a:srgbClr val="E2E8F0"/>
-                </a:solidFill>
-                <a:latin typeface="Arial"/>
-              </a:defRPr>
-            </a:pPr>
-            <a:r>
-              <a:t>   Nuestra militancia y coordinadores están blindados con tokens efímeros y formularios sin residuo en teléfono.</a:t>
+              <a:defRPr sz="1150">
+                <a:solidFill>
+                  <a:srgbClr val="334155"/>
+                </a:solidFill>
+                <a:latin typeface="Arial"/>
+              </a:defRPr>
+            </a:pPr>
+            <a:r>
+              <a:t>   El esquema de tokens web efímeros y formularios sin almacenamiento residual en dispositivos brinda tranquilidad y resguardo absoluto a la militancia.</a:t>
             </a:r>
           </a:p>
           <a:p>
             <a:pPr>
               <a:spcAft>
-                <a:spcPts val="400"/>
+                <a:spcPts val="200"/>
               </a:spcAft>
-              <a:defRPr sz="1300" b="1">
-                <a:solidFill>
-                  <a:srgbClr val="FFFFFF"/>
-                </a:solidFill>
-                <a:latin typeface="Arial"/>
-              </a:defRPr>
-            </a:pPr>
-            <a:r>
-              <a:t>• Máxima Rentabilidad Política: </a:t>
+              <a:defRPr sz="1200" b="1">
+                <a:solidFill>
+                  <a:srgbClr val="0F172A"/>
+                </a:solidFill>
+                <a:latin typeface="Arial"/>
+              </a:defRPr>
+            </a:pPr>
+            <a:r>
+              <a:t>▪ Alta Rentabilidad de la Inversión: </a:t>
             </a:r>
           </a:p>
           <a:p>
             <a:pPr>
               <a:spcAft>
-                <a:spcPts val="1000"/>
+                <a:spcPts val="800"/>
               </a:spcAft>
-              <a:defRPr sz="1200">
-                <a:solidFill>
-                  <a:srgbClr val="E2E8F0"/>
-                </a:solidFill>
-                <a:latin typeface="Arial"/>
-              </a:defRPr>
-            </a:pPr>
-            <a:r>
-              <a:t>   Con solo $294.00 USD anuales, MIGATO se posiciona a la vanguardia organizativa del oriente del país.</a:t>
+              <a:defRPr sz="1150">
+                <a:solidFill>
+                  <a:srgbClr val="334155"/>
+                </a:solidFill>
+                <a:latin typeface="Arial"/>
+              </a:defRPr>
+            </a:pPr>
+            <a:r>
+              <a:t>   El monto solicitado ($294.00 USD anuales) cubre exclusivamente costos directos de servidor cloud, representando un valor mínimo frente a su alto impacto estratégico.</a:t>
             </a:r>
           </a:p>
           <a:p>
@@ -4698,15 +4698,15 @@
               <a:spcBef>
                 <a:spcPts val="800"/>
               </a:spcBef>
-              <a:defRPr sz="1300" b="1">
-                <a:solidFill>
-                  <a:srgbClr val="4ADE80"/>
-                </a:solidFill>
-                <a:latin typeface="Arial"/>
-              </a:defRPr>
-            </a:pPr>
-            <a:r>
-              <a:t>RECOMENDACIÓN FINAL: Aprobar la contratación de la Fase 1 ($294.00 USD) para encender el servidor y comenzar de inmediato las pruebas piloto en Maturín.</a:t>
+              <a:defRPr sz="1250" b="1">
+                <a:solidFill>
+                  <a:srgbClr val="1E3A8A"/>
+                </a:solidFill>
+                <a:latin typeface="Arial"/>
+              </a:defRPr>
+            </a:pPr>
+            <a:r>
+              <a:t>RECOMENDACIÓN FINAL: Aprobar el presupuesto operativo de $294.00 USD anuales para proceder de inmediato con la contratación del servidor dedicado y el encendido formal de la Fase 1 del proyecto.</a:t>
             </a:r>
           </a:p>
         </p:txBody>
@@ -4744,7 +4744,7 @@
             <a:avLst/>
           </a:prstGeom>
           <a:solidFill>
-            <a:srgbClr val="0F172A"/>
+            <a:srgbClr val="F8FAFC"/>
           </a:solidFill>
           <a:ln>
             <a:noFill/>
@@ -4781,7 +4781,7 @@
         <p:spPr>
           <a:xfrm>
             <a:off x="731520" y="365760"/>
-            <a:ext cx="9144000" cy="365760"/>
+            <a:ext cx="9144000" cy="320040"/>
           </a:xfrm>
           <a:prstGeom prst="rect">
             <a:avLst/>
@@ -4795,15 +4795,15 @@
           <a:lstStyle/>
           <a:p>
             <a:pPr>
-              <a:defRPr sz="1100" b="1">
-                <a:solidFill>
-                  <a:srgbClr val="38BDF8"/>
-                </a:solidFill>
-                <a:latin typeface="Arial"/>
-              </a:defRPr>
-            </a:pPr>
-            <a:r>
-              <a:t>MIGATO • EQUIPO TÉCNICO DE SISTEMAS</a:t>
+              <a:defRPr sz="1000" b="1">
+                <a:solidFill>
+                  <a:srgbClr val="0284C7"/>
+                </a:solidFill>
+                <a:latin typeface="Arial"/>
+              </a:defRPr>
+            </a:pPr>
+            <a:r>
+              <a:t>MIGATO • EQUIPO TÉCNICO DE SISTEMAS Y ARQUITECTURA DIGITAL</a:t>
             </a:r>
           </a:p>
         </p:txBody>
@@ -4816,8 +4816,8 @@
         </p:nvSpPr>
         <p:spPr>
           <a:xfrm>
-            <a:off x="731520" y="685800"/>
-            <a:ext cx="9601200" cy="731520"/>
+            <a:off x="731520" y="658368"/>
+            <a:ext cx="9601200" cy="685800"/>
           </a:xfrm>
           <a:prstGeom prst="rect">
             <a:avLst/>
@@ -4831,15 +4831,15 @@
           <a:lstStyle/>
           <a:p>
             <a:pPr>
-              <a:defRPr sz="2400" b="1">
-                <a:solidFill>
-                  <a:srgbClr val="FFFFFF"/>
-                </a:solidFill>
-                <a:latin typeface="Arial"/>
-              </a:defRPr>
-            </a:pPr>
-            <a:r>
-              <a:t>El Desafío en Monagas: Centralismo Ineficiente vs. Rigor Gerencial</a:t>
+              <a:defRPr sz="2200" b="1">
+                <a:solidFill>
+                  <a:srgbClr val="0F172A"/>
+                </a:solidFill>
+                <a:latin typeface="Arial"/>
+              </a:defRPr>
+            </a:pPr>
+            <a:r>
+              <a:t>Marco Estratégico: Superación del Centralismo Burocrático</a:t>
             </a:r>
           </a:p>
         </p:txBody>
@@ -4861,7 +4861,7 @@
         <p:spPr>
           <a:xfrm>
             <a:off x="10789920" y="365760"/>
-            <a:ext cx="731520" cy="731520"/>
+            <a:ext cx="685800" cy="685800"/>
           </a:xfrm>
           <a:prstGeom prst="rect">
             <a:avLst/>
@@ -4876,14 +4876,14 @@
         </p:nvSpPr>
         <p:spPr>
           <a:xfrm>
-            <a:off x="731520" y="1463040"/>
+            <a:off x="731520" y="1371600"/>
             <a:ext cx="10728655" cy="18288"/>
           </a:xfrm>
           <a:prstGeom prst="rect">
             <a:avLst/>
           </a:prstGeom>
           <a:solidFill>
-            <a:srgbClr val="334155"/>
+            <a:srgbClr val="1E3A8A"/>
           </a:solidFill>
           <a:ln>
             <a:noFill/>
@@ -4919,18 +4919,18 @@
         </p:nvSpPr>
         <p:spPr>
           <a:xfrm>
-            <a:off x="731520" y="1737360"/>
-            <a:ext cx="5120640" cy="4389120"/>
+            <a:off x="731520" y="1645920"/>
+            <a:ext cx="5120640" cy="4572000"/>
           </a:xfrm>
           <a:prstGeom prst="roundRect">
             <a:avLst/>
           </a:prstGeom>
           <a:solidFill>
-            <a:srgbClr val="1E293B"/>
+            <a:srgbClr val="FFFFFF"/>
           </a:solidFill>
           <a:ln>
             <a:solidFill>
-              <a:srgbClr val="EF4444"/>
+              <a:srgbClr val="CBD5E1"/>
             </a:solidFill>
           </a:ln>
         </p:spPr>
@@ -4964,8 +4964,8 @@
         </p:nvSpPr>
         <p:spPr>
           <a:xfrm>
-            <a:off x="1005840" y="1920240"/>
-            <a:ext cx="4572000" cy="4023360"/>
+            <a:off x="1005840" y="1828800"/>
+            <a:ext cx="4572000" cy="4114800"/>
           </a:xfrm>
           <a:prstGeom prst="rect">
             <a:avLst/>
@@ -4980,17 +4980,17 @@
           <a:p>
             <a:pPr>
               <a:spcAft>
-                <a:spcPts val="1400"/>
+                <a:spcPts val="1200"/>
               </a:spcAft>
-              <a:defRPr sz="1600" b="1">
-                <a:solidFill>
-                  <a:srgbClr val="F87171"/>
-                </a:solidFill>
-                <a:latin typeface="Arial"/>
-              </a:defRPr>
-            </a:pPr>
-            <a:r>
-              <a:t>⚠️ El Esquema Actual (Colapso e Improvisación)</a:t>
+              <a:defRPr sz="1500" b="1">
+                <a:solidFill>
+                  <a:srgbClr val="DC2626"/>
+                </a:solidFill>
+                <a:latin typeface="Arial"/>
+              </a:defRPr>
+            </a:pPr>
+            <a:r>
+              <a:t>⚠️ Limitaciones del Esquema Tradicional</a:t>
             </a:r>
           </a:p>
           <a:p>
@@ -4998,15 +4998,15 @@
               <a:spcAft>
                 <a:spcPts val="800"/>
               </a:spcAft>
-              <a:defRPr sz="1300">
-                <a:solidFill>
-                  <a:srgbClr val="E2E8F0"/>
-                </a:solidFill>
-                <a:latin typeface="Arial"/>
-              </a:defRPr>
-            </a:pPr>
-            <a:r>
-              <a:t>• Servicios públicos colapsados: hospitales sin luz ni agua, transformadores dañados y vialidad destruida.</a:t>
+              <a:defRPr sz="1200">
+                <a:solidFill>
+                  <a:srgbClr val="334155"/>
+                </a:solidFill>
+                <a:latin typeface="Arial"/>
+              </a:defRPr>
+            </a:pPr>
+            <a:r>
+              <a:t>▪ Precarización de servicios esenciales: fallas sostenidas en la red eléctrica, suministro de agua y vialidad.</a:t>
             </a:r>
           </a:p>
           <a:p>
@@ -5014,15 +5014,15 @@
               <a:spcAft>
                 <a:spcPts val="800"/>
               </a:spcAft>
-              <a:defRPr sz="1300">
-                <a:solidFill>
-                  <a:srgbClr val="E2E8F0"/>
-                </a:solidFill>
-                <a:latin typeface="Arial"/>
-              </a:defRPr>
-            </a:pPr>
-            <a:r>
-              <a:t>• Manejo burocrático y clientelar que carece de métricas técnicas reales de la población.</a:t>
+              <a:defRPr sz="1200">
+                <a:solidFill>
+                  <a:srgbClr val="334155"/>
+                </a:solidFill>
+                <a:latin typeface="Arial"/>
+              </a:defRPr>
+            </a:pPr>
+            <a:r>
+              <a:t>▪ Gestión sin métricas objetivas: ausencia de levantamiento técnico y decisiones basadas en criterios clientelares.</a:t>
             </a:r>
           </a:p>
           <a:p>
@@ -5030,15 +5030,15 @@
               <a:spcAft>
                 <a:spcPts val="800"/>
               </a:spcAft>
-              <a:defRPr sz="1300">
-                <a:solidFill>
-                  <a:srgbClr val="E2E8F0"/>
-                </a:solidFill>
-                <a:latin typeface="Arial"/>
-              </a:defRPr>
-            </a:pPr>
-            <a:r>
-              <a:t>• Comunicaciones en grupos masivos de WhatsApp: datos dispersos, fugas de información y riesgo de espionaje.</a:t>
+              <a:defRPr sz="1200">
+                <a:solidFill>
+                  <a:srgbClr val="334155"/>
+                </a:solidFill>
+                <a:latin typeface="Arial"/>
+              </a:defRPr>
+            </a:pPr>
+            <a:r>
+              <a:t>▪ Riesgos en canales informales: la dispersión en grupos de mensajería compromete la confidencialidad y dificulta la consolidación.</a:t>
             </a:r>
           </a:p>
           <a:p>
@@ -5046,15 +5046,15 @@
               <a:spcAft>
                 <a:spcPts val="800"/>
               </a:spcAft>
-              <a:defRPr sz="1300">
-                <a:solidFill>
-                  <a:srgbClr val="E2E8F0"/>
-                </a:solidFill>
-                <a:latin typeface="Arial"/>
-              </a:defRPr>
-            </a:pPr>
-            <a:r>
-              <a:t>• Exposición de la militancia ante revisiones indebidas de teléfonos en la calle.</a:t>
+              <a:defRPr sz="1200">
+                <a:solidFill>
+                  <a:srgbClr val="334155"/>
+                </a:solidFill>
+                <a:latin typeface="Arial"/>
+              </a:defRPr>
+            </a:pPr>
+            <a:r>
+              <a:t>▪ Vulnerabilidad operativa: exposición de los activistas comunitarios ante revisiones no autorizadas de dispositivos en campo.</a:t>
             </a:r>
           </a:p>
         </p:txBody>
@@ -5067,18 +5067,18 @@
         </p:nvSpPr>
         <p:spPr>
           <a:xfrm>
-            <a:off x="6217920" y="1737360"/>
-            <a:ext cx="5212080" cy="4389120"/>
+            <a:off x="6217920" y="1645920"/>
+            <a:ext cx="5212080" cy="4572000"/>
           </a:xfrm>
           <a:prstGeom prst="roundRect">
             <a:avLst/>
           </a:prstGeom>
           <a:solidFill>
-            <a:srgbClr val="1E293B"/>
+            <a:srgbClr val="FFFFFF"/>
           </a:solidFill>
           <a:ln>
             <a:solidFill>
-              <a:srgbClr val="0284C7"/>
+              <a:srgbClr val="1E3A8A"/>
             </a:solidFill>
           </a:ln>
         </p:spPr>
@@ -5112,8 +5112,8 @@
         </p:nvSpPr>
         <p:spPr>
           <a:xfrm>
-            <a:off x="6492240" y="1920240"/>
-            <a:ext cx="4663440" cy="4023360"/>
+            <a:off x="6492240" y="1828800"/>
+            <a:ext cx="4663440" cy="4114800"/>
           </a:xfrm>
           <a:prstGeom prst="rect">
             <a:avLst/>
@@ -5128,17 +5128,17 @@
           <a:p>
             <a:pPr>
               <a:spcAft>
-                <a:spcPts val="1400"/>
+                <a:spcPts val="1200"/>
               </a:spcAft>
-              <a:defRPr sz="1600" b="1">
-                <a:solidFill>
-                  <a:srgbClr val="38BDF8"/>
-                </a:solidFill>
-                <a:latin typeface="Arial"/>
-              </a:defRPr>
-            </a:pPr>
-            <a:r>
-              <a:t>🏛️ La Alternativa MIGATO (Orden y Gerencia Privada)</a:t>
+              <a:defRPr sz="1500" b="1">
+                <a:solidFill>
+                  <a:srgbClr val="1E3A8A"/>
+                </a:solidFill>
+                <a:latin typeface="Arial"/>
+              </a:defRPr>
+            </a:pPr>
+            <a:r>
+              <a:t>🏛️ La Propuesta Gerencial de MIGATO</a:t>
             </a:r>
           </a:p>
           <a:p>
@@ -5146,15 +5146,15 @@
               <a:spcAft>
                 <a:spcPts val="800"/>
               </a:spcAft>
-              <a:defRPr sz="1300">
-                <a:solidFill>
-                  <a:srgbClr val="E2E8F0"/>
-                </a:solidFill>
-                <a:latin typeface="Arial"/>
-              </a:defRPr>
-            </a:pPr>
-            <a:r>
-              <a:t>• Supremacía del mérito técnico, eficiencia y estándares corporativos de primer mundo.</a:t>
+              <a:defRPr sz="1200">
+                <a:solidFill>
+                  <a:srgbClr val="334155"/>
+                </a:solidFill>
+                <a:latin typeface="Arial"/>
+              </a:defRPr>
+            </a:pPr>
+            <a:r>
+              <a:t>▪ Estándares corporativos de primer nivel: implementación de orden, método y rigurosidad técnica en la gestión pública.</a:t>
             </a:r>
           </a:p>
           <a:p>
@@ -5162,15 +5162,15 @@
               <a:spcAft>
                 <a:spcPts val="800"/>
               </a:spcAft>
-              <a:defRPr sz="1300">
-                <a:solidFill>
-                  <a:srgbClr val="E2E8F0"/>
-                </a:solidFill>
-                <a:latin typeface="Arial"/>
-              </a:defRPr>
-            </a:pPr>
-            <a:r>
-              <a:t>• Toma de decisiones fundamentada en mapas georreferenciados y datos reales no manipulables.</a:t>
+              <a:defRPr sz="1200">
+                <a:solidFill>
+                  <a:srgbClr val="334155"/>
+                </a:solidFill>
+                <a:latin typeface="Arial"/>
+              </a:defRPr>
+            </a:pPr>
+            <a:r>
+              <a:t>▪ Decisiones con respaldo empírico: información georreferenciada y métricas confiables de las comunidades en tiempo real.</a:t>
             </a:r>
           </a:p>
           <a:p>
@@ -5178,15 +5178,15 @@
               <a:spcAft>
                 <a:spcPts val="800"/>
               </a:spcAft>
-              <a:defRPr sz="1300">
-                <a:solidFill>
-                  <a:srgbClr val="E2E8F0"/>
-                </a:solidFill>
-                <a:latin typeface="Arial"/>
-              </a:defRPr>
-            </a:pPr>
-            <a:r>
-              <a:t>• Plataforma centralizada con canales de comunicación compartimentados y enlaces directos seguros.</a:t>
+              <a:defRPr sz="1200">
+                <a:solidFill>
+                  <a:srgbClr val="334155"/>
+                </a:solidFill>
+                <a:latin typeface="Arial"/>
+              </a:defRPr>
+            </a:pPr>
+            <a:r>
+              <a:t>▪ Comunicación estructurada y segura: canales compartimentados por parroquia con trazabilidad institucional.</a:t>
             </a:r>
           </a:p>
           <a:p>
@@ -5194,15 +5194,15 @@
               <a:spcAft>
                 <a:spcPts val="800"/>
               </a:spcAft>
-              <a:defRPr sz="1300">
-                <a:solidFill>
-                  <a:srgbClr val="E2E8F0"/>
-                </a:solidFill>
-                <a:latin typeface="Arial"/>
-              </a:defRPr>
-            </a:pPr>
-            <a:r>
-              <a:t>• Soberanía tecnológica: las bases de datos pertenecen al partido en un servidor privado exclusivo.</a:t>
+              <a:defRPr sz="1200">
+                <a:solidFill>
+                  <a:srgbClr val="334155"/>
+                </a:solidFill>
+                <a:latin typeface="Arial"/>
+              </a:defRPr>
+            </a:pPr>
+            <a:r>
+              <a:t>▪ Soberanía de la información: bases de datos resguardadas en un servidor cloud dedicado bajo control exclusivo del partido.</a:t>
             </a:r>
           </a:p>
         </p:txBody>
@@ -5240,7 +5240,7 @@
             <a:avLst/>
           </a:prstGeom>
           <a:solidFill>
-            <a:srgbClr val="0F172A"/>
+            <a:srgbClr val="F8FAFC"/>
           </a:solidFill>
           <a:ln>
             <a:noFill/>
@@ -5277,7 +5277,7 @@
         <p:spPr>
           <a:xfrm>
             <a:off x="731520" y="365760"/>
-            <a:ext cx="9144000" cy="365760"/>
+            <a:ext cx="9144000" cy="320040"/>
           </a:xfrm>
           <a:prstGeom prst="rect">
             <a:avLst/>
@@ -5291,15 +5291,15 @@
           <a:lstStyle/>
           <a:p>
             <a:pPr>
-              <a:defRPr sz="1100" b="1">
-                <a:solidFill>
-                  <a:srgbClr val="38BDF8"/>
-                </a:solidFill>
-                <a:latin typeface="Arial"/>
-              </a:defRPr>
-            </a:pPr>
-            <a:r>
-              <a:t>MIGATO • EQUIPO TÉCNICO DE SISTEMAS</a:t>
+              <a:defRPr sz="1000" b="1">
+                <a:solidFill>
+                  <a:srgbClr val="0284C7"/>
+                </a:solidFill>
+                <a:latin typeface="Arial"/>
+              </a:defRPr>
+            </a:pPr>
+            <a:r>
+              <a:t>MIGATO • EQUIPO TÉCNICO DE SISTEMAS Y ARQUITECTURA DIGITAL</a:t>
             </a:r>
           </a:p>
         </p:txBody>
@@ -5312,8 +5312,8 @@
         </p:nvSpPr>
         <p:spPr>
           <a:xfrm>
-            <a:off x="731520" y="685800"/>
-            <a:ext cx="9601200" cy="731520"/>
+            <a:off x="731520" y="658368"/>
+            <a:ext cx="9601200" cy="685800"/>
           </a:xfrm>
           <a:prstGeom prst="rect">
             <a:avLst/>
@@ -5327,15 +5327,15 @@
           <a:lstStyle/>
           <a:p>
             <a:pPr>
-              <a:defRPr sz="2400" b="1">
-                <a:solidFill>
-                  <a:srgbClr val="FFFFFF"/>
-                </a:solidFill>
-                <a:latin typeface="Arial"/>
-              </a:defRPr>
-            </a:pPr>
-            <a:r>
-              <a:t>La Solución: Plataforma Territorial MIGATO en 5 Módulos</a:t>
+              <a:defRPr sz="2200" b="1">
+                <a:solidFill>
+                  <a:srgbClr val="0F172A"/>
+                </a:solidFill>
+                <a:latin typeface="Arial"/>
+              </a:defRPr>
+            </a:pPr>
+            <a:r>
+              <a:t>Solución Integral: Plataforma Territorial en 5 Módulos</a:t>
             </a:r>
           </a:p>
         </p:txBody>
@@ -5357,7 +5357,7 @@
         <p:spPr>
           <a:xfrm>
             <a:off x="10789920" y="365760"/>
-            <a:ext cx="731520" cy="731520"/>
+            <a:ext cx="685800" cy="685800"/>
           </a:xfrm>
           <a:prstGeom prst="rect">
             <a:avLst/>
@@ -5372,14 +5372,14 @@
         </p:nvSpPr>
         <p:spPr>
           <a:xfrm>
-            <a:off x="731520" y="1463040"/>
+            <a:off x="731520" y="1371600"/>
             <a:ext cx="10728655" cy="18288"/>
           </a:xfrm>
           <a:prstGeom prst="rect">
             <a:avLst/>
           </a:prstGeom>
           <a:solidFill>
-            <a:srgbClr val="334155"/>
+            <a:srgbClr val="1E3A8A"/>
           </a:solidFill>
           <a:ln>
             <a:noFill/>
@@ -5422,11 +5422,11 @@
             <a:avLst/>
           </a:prstGeom>
           <a:solidFill>
-            <a:srgbClr val="1E293B"/>
+            <a:srgbClr val="FFFFFF"/>
           </a:solidFill>
           <a:ln>
             <a:solidFill>
-              <a:srgbClr val="0284C7"/>
+              <a:srgbClr val="CBD5E1"/>
             </a:solidFill>
           </a:ln>
         </p:spPr>
@@ -5475,28 +5475,28 @@
           <a:lstStyle/>
           <a:p>
             <a:pPr>
-              <a:defRPr sz="1400" b="1">
-                <a:solidFill>
-                  <a:srgbClr val="0284C7"/>
-                </a:solidFill>
-                <a:latin typeface="Arial"/>
-              </a:defRPr>
-            </a:pPr>
-            <a:r>
-              <a:t>Módulo 1: Despacho Celular  </a:t>
+              <a:defRPr sz="1350" b="1">
+                <a:solidFill>
+                  <a:srgbClr val="1E3A8A"/>
+                </a:solidFill>
+                <a:latin typeface="Arial"/>
+              </a:defRPr>
+            </a:pPr>
+            <a:r>
+              <a:t>Módulo 1: Despacho Celular Seguro   </a:t>
             </a:r>
           </a:p>
           <a:p>
             <a:pPr>
-              <a:defRPr sz="1150">
-                <a:solidFill>
-                  <a:srgbClr val="E2E8F0"/>
-                </a:solidFill>
-                <a:latin typeface="Arial"/>
-              </a:defRPr>
-            </a:pPr>
-            <a:r>
-              <a:t>Ruta: /despacho/ • Enlaces por token web único directo al teléfono del coordinador parroquial. Cero contraseñas complicadas y compartimentación geográfica.</a:t>
+              <a:defRPr sz="1100">
+                <a:solidFill>
+                  <a:srgbClr val="334155"/>
+                </a:solidFill>
+                <a:latin typeface="Arial"/>
+              </a:defRPr>
+            </a:pPr>
+            <a:r>
+              <a:t>Consola: /despacho/ • Enlaces cifrados por token web temporal directo al coordinador. Sin contraseñas complejas y con compartimentación territorial.</a:t>
             </a:r>
           </a:p>
         </p:txBody>
@@ -5516,11 +5516,11 @@
             <a:avLst/>
           </a:prstGeom>
           <a:solidFill>
-            <a:srgbClr val="1E293B"/>
+            <a:srgbClr val="FFFFFF"/>
           </a:solidFill>
           <a:ln>
             <a:solidFill>
-              <a:srgbClr val="38BDF8"/>
+              <a:srgbClr val="CBD5E1"/>
             </a:solidFill>
           </a:ln>
         </p:spPr>
@@ -5569,28 +5569,28 @@
           <a:lstStyle/>
           <a:p>
             <a:pPr>
-              <a:defRPr sz="1400" b="1">
-                <a:solidFill>
-                  <a:srgbClr val="38BDF8"/>
-                </a:solidFill>
-                <a:latin typeface="Arial"/>
-              </a:defRPr>
-            </a:pPr>
-            <a:r>
-              <a:t>Módulo 2: Censo Comunitario  </a:t>
+              <a:defRPr sz="1350" b="1">
+                <a:solidFill>
+                  <a:srgbClr val="1E3A8A"/>
+                </a:solidFill>
+                <a:latin typeface="Arial"/>
+              </a:defRPr>
+            </a:pPr>
+            <a:r>
+              <a:t>Módulo 2: Censo Territorial y Privacidad   </a:t>
             </a:r>
           </a:p>
           <a:p>
             <a:pPr>
-              <a:defRPr sz="1150">
-                <a:solidFill>
-                  <a:srgbClr val="E2E8F0"/>
-                </a:solidFill>
-                <a:latin typeface="Arial"/>
-              </a:defRPr>
-            </a:pPr>
-            <a:r>
-              <a:t>Ruta: /carga/ • Protocolo 'Buzón Ciego': no guarda datos personales ni cédulas. Al enviar se borra del teléfono (Zero-Byte Storage).</a:t>
+              <a:defRPr sz="1100">
+                <a:solidFill>
+                  <a:srgbClr val="334155"/>
+                </a:solidFill>
+                <a:latin typeface="Arial"/>
+              </a:defRPr>
+            </a:pPr>
+            <a:r>
+              <a:t>Consola: /carga/ • Protocolo de Cero Residuos en Dispositivo: registra variables cuantitativas de servicios sin almacenar datos personales ni cédulas.</a:t>
             </a:r>
           </a:p>
         </p:txBody>
@@ -5610,11 +5610,11 @@
             <a:avLst/>
           </a:prstGeom>
           <a:solidFill>
-            <a:srgbClr val="1E293B"/>
+            <a:srgbClr val="FFFFFF"/>
           </a:solidFill>
           <a:ln>
             <a:solidFill>
-              <a:srgbClr val="4ADE80"/>
+              <a:srgbClr val="CBD5E1"/>
             </a:solidFill>
           </a:ln>
         </p:spPr>
@@ -5663,28 +5663,28 @@
           <a:lstStyle/>
           <a:p>
             <a:pPr>
-              <a:defRPr sz="1400" b="1">
-                <a:solidFill>
-                  <a:srgbClr val="4ADE80"/>
-                </a:solidFill>
-                <a:latin typeface="Arial"/>
-              </a:defRPr>
-            </a:pPr>
-            <a:r>
-              <a:t>Módulo 3: Padrón y Actas  </a:t>
+              <a:defRPr sz="1350" b="1">
+                <a:solidFill>
+                  <a:srgbClr val="1E3A8A"/>
+                </a:solidFill>
+                <a:latin typeface="Arial"/>
+              </a:defRPr>
+            </a:pPr>
+            <a:r>
+              <a:t>Módulo 3: Padrón Electoral y Actas   </a:t>
             </a:r>
           </a:p>
           <a:p>
             <a:pPr>
-              <a:defRPr sz="1150">
-                <a:solidFill>
-                  <a:srgbClr val="E2E8F0"/>
-                </a:solidFill>
-                <a:latin typeface="Arial"/>
-              </a:defRPr>
-            </a:pPr>
-            <a:r>
-              <a:t>Ruta: /centros-maturin/ • 175 centros y 361 mesas de Maturín. Asignación de testigos y resguardo fotográfico de actas y código QR para cotejo interno.</a:t>
+              <a:defRPr sz="1100">
+                <a:solidFill>
+                  <a:srgbClr val="334155"/>
+                </a:solidFill>
+                <a:latin typeface="Arial"/>
+              </a:defRPr>
+            </a:pPr>
+            <a:r>
+              <a:t>Consola: /centros-maturin/ • Catálogo de 175 centros y 361 mesas de Maturín. Organización de testigos y respaldo fotográfico de actas y código QR para auditoría interna.</a:t>
             </a:r>
           </a:p>
         </p:txBody>
@@ -5704,11 +5704,11 @@
             <a:avLst/>
           </a:prstGeom>
           <a:solidFill>
-            <a:srgbClr val="1E293B"/>
+            <a:srgbClr val="FFFFFF"/>
           </a:solidFill>
           <a:ln>
             <a:solidFill>
-              <a:srgbClr val="0284C7"/>
+              <a:srgbClr val="CBD5E1"/>
             </a:solidFill>
           </a:ln>
         </p:spPr>
@@ -5757,28 +5757,28 @@
           <a:lstStyle/>
           <a:p>
             <a:pPr>
-              <a:defRPr sz="1400" b="1">
-                <a:solidFill>
-                  <a:srgbClr val="0284C7"/>
-                </a:solidFill>
-                <a:latin typeface="Arial"/>
-              </a:defRPr>
-            </a:pPr>
-            <a:r>
-              <a:t>Módulo 4: Cartografía 3D  </a:t>
+              <a:defRPr sz="1350" b="1">
+                <a:solidFill>
+                  <a:srgbClr val="1E3A8A"/>
+                </a:solidFill>
+                <a:latin typeface="Arial"/>
+              </a:defRPr>
+            </a:pPr>
+            <a:r>
+              <a:t>Módulo 4: Cartografía Tridimensional   </a:t>
             </a:r>
           </a:p>
           <a:p>
             <a:pPr>
-              <a:defRPr sz="1150">
-                <a:solidFill>
-                  <a:srgbClr val="E2E8F0"/>
-                </a:solidFill>
-                <a:latin typeface="Arial"/>
-              </a:defRPr>
-            </a:pPr>
-            <a:r>
-              <a:t>Ruta: /earth-monagas/ • Consola 3D de vialidad, relieve y servicios, con filtro de focalización territorial para resaltar el área analizada.</a:t>
+              <a:defRPr sz="1100">
+                <a:solidFill>
+                  <a:srgbClr val="334155"/>
+                </a:solidFill>
+                <a:latin typeface="Arial"/>
+              </a:defRPr>
+            </a:pPr>
+            <a:r>
+              <a:t>Consola: /earth-monagas/ • Consola 3D de vialidad, relieve y servicios con filtro de focalización territorial para mesas de planificación estratégica.</a:t>
             </a:r>
           </a:p>
         </p:txBody>
@@ -5798,11 +5798,11 @@
             <a:avLst/>
           </a:prstGeom>
           <a:solidFill>
-            <a:srgbClr val="1E293B"/>
+            <a:srgbClr val="FFFFFF"/>
           </a:solidFill>
           <a:ln>
             <a:solidFill>
-              <a:srgbClr val="38BDF8"/>
+              <a:srgbClr val="CBD5E1"/>
             </a:solidFill>
           </a:ln>
         </p:spPr>
@@ -5851,28 +5851,28 @@
           <a:lstStyle/>
           <a:p>
             <a:pPr>
-              <a:defRPr sz="1400" b="1">
-                <a:solidFill>
-                  <a:srgbClr val="38BDF8"/>
-                </a:solidFill>
-                <a:latin typeface="Arial"/>
-              </a:defRPr>
-            </a:pPr>
-            <a:r>
-              <a:t>Módulo 5: Red de Salud  </a:t>
+              <a:defRPr sz="1350" b="1">
+                <a:solidFill>
+                  <a:srgbClr val="1E3A8A"/>
+                </a:solidFill>
+                <a:latin typeface="Arial"/>
+              </a:defRPr>
+            </a:pPr>
+            <a:r>
+              <a:t>Módulo 5: Diagnóstico de Salud Regional   </a:t>
             </a:r>
           </a:p>
           <a:p>
             <a:pPr>
-              <a:defRPr sz="1150">
-                <a:solidFill>
-                  <a:srgbClr val="E2E8F0"/>
-                </a:solidFill>
-                <a:latin typeface="Arial"/>
-              </a:defRPr>
-            </a:pPr>
-            <a:r>
-              <a:t>Ruta: /salud-monagas/ • Auditoría en tiempo real de 84 centros asistenciales: plantas eléctricas, agua, quirófanos y rutas de derivación médica.</a:t>
+              <a:defRPr sz="1100">
+                <a:solidFill>
+                  <a:srgbClr val="334155"/>
+                </a:solidFill>
+                <a:latin typeface="Arial"/>
+              </a:defRPr>
+            </a:pPr>
+            <a:r>
+              <a:t>Consola: /salud-monagas/ • Supervisión técnica de 84 centros asistenciales: plantas eléctricas, agua, quirófanos y base fehaciente para planes de gobierno.</a:t>
             </a:r>
           </a:p>
         </p:txBody>
@@ -5910,7 +5910,7 @@
             <a:avLst/>
           </a:prstGeom>
           <a:solidFill>
-            <a:srgbClr val="0F172A"/>
+            <a:srgbClr val="F8FAFC"/>
           </a:solidFill>
           <a:ln>
             <a:noFill/>
@@ -5947,7 +5947,7 @@
         <p:spPr>
           <a:xfrm>
             <a:off x="731520" y="365760"/>
-            <a:ext cx="9144000" cy="365760"/>
+            <a:ext cx="9144000" cy="320040"/>
           </a:xfrm>
           <a:prstGeom prst="rect">
             <a:avLst/>
@@ -5961,15 +5961,15 @@
           <a:lstStyle/>
           <a:p>
             <a:pPr>
-              <a:defRPr sz="1100" b="1">
-                <a:solidFill>
-                  <a:srgbClr val="38BDF8"/>
-                </a:solidFill>
-                <a:latin typeface="Arial"/>
-              </a:defRPr>
-            </a:pPr>
-            <a:r>
-              <a:t>MIGATO • EQUIPO TÉCNICO DE SISTEMAS</a:t>
+              <a:defRPr sz="1000" b="1">
+                <a:solidFill>
+                  <a:srgbClr val="0284C7"/>
+                </a:solidFill>
+                <a:latin typeface="Arial"/>
+              </a:defRPr>
+            </a:pPr>
+            <a:r>
+              <a:t>MIGATO • EQUIPO TÉCNICO DE SISTEMAS Y ARQUITECTURA DIGITAL</a:t>
             </a:r>
           </a:p>
         </p:txBody>
@@ -5982,8 +5982,8 @@
         </p:nvSpPr>
         <p:spPr>
           <a:xfrm>
-            <a:off x="731520" y="685800"/>
-            <a:ext cx="9601200" cy="731520"/>
+            <a:off x="731520" y="658368"/>
+            <a:ext cx="9601200" cy="685800"/>
           </a:xfrm>
           <a:prstGeom prst="rect">
             <a:avLst/>
@@ -5997,15 +5997,15 @@
           <a:lstStyle/>
           <a:p>
             <a:pPr>
-              <a:defRPr sz="2400" b="1">
-                <a:solidFill>
-                  <a:srgbClr val="FFFFFF"/>
-                </a:solidFill>
-                <a:latin typeface="Arial"/>
-              </a:defRPr>
-            </a:pPr>
-            <a:r>
-              <a:t>Módulos 1 y 2: Coordinación Parroquial y Censo Protegido</a:t>
+              <a:defRPr sz="2200" b="1">
+                <a:solidFill>
+                  <a:srgbClr val="0F172A"/>
+                </a:solidFill>
+                <a:latin typeface="Arial"/>
+              </a:defRPr>
+            </a:pPr>
+            <a:r>
+              <a:t>Módulos 1 y 2: Coordinación Parroquial y Protección de Datos</a:t>
             </a:r>
           </a:p>
         </p:txBody>
@@ -6027,7 +6027,7 @@
         <p:spPr>
           <a:xfrm>
             <a:off x="10789920" y="365760"/>
-            <a:ext cx="731520" cy="731520"/>
+            <a:ext cx="685800" cy="685800"/>
           </a:xfrm>
           <a:prstGeom prst="rect">
             <a:avLst/>
@@ -6042,14 +6042,14 @@
         </p:nvSpPr>
         <p:spPr>
           <a:xfrm>
-            <a:off x="731520" y="1463040"/>
+            <a:off x="731520" y="1371600"/>
             <a:ext cx="10728655" cy="18288"/>
           </a:xfrm>
           <a:prstGeom prst="rect">
             <a:avLst/>
           </a:prstGeom>
           <a:solidFill>
-            <a:srgbClr val="334155"/>
+            <a:srgbClr val="1E3A8A"/>
           </a:solidFill>
           <a:ln>
             <a:noFill/>
@@ -6085,18 +6085,18 @@
         </p:nvSpPr>
         <p:spPr>
           <a:xfrm>
-            <a:off x="731520" y="1737360"/>
-            <a:ext cx="5120640" cy="4389120"/>
+            <a:off x="731520" y="1645920"/>
+            <a:ext cx="5120640" cy="4572000"/>
           </a:xfrm>
           <a:prstGeom prst="roundRect">
             <a:avLst/>
           </a:prstGeom>
           <a:solidFill>
-            <a:srgbClr val="1E293B"/>
+            <a:srgbClr val="FFFFFF"/>
           </a:solidFill>
           <a:ln>
             <a:solidFill>
-              <a:srgbClr val="0284C7"/>
+              <a:srgbClr val="CBD5E1"/>
             </a:solidFill>
           </a:ln>
         </p:spPr>
@@ -6130,8 +6130,8 @@
         </p:nvSpPr>
         <p:spPr>
           <a:xfrm>
-            <a:off x="1005840" y="1920240"/>
-            <a:ext cx="4572000" cy="4023360"/>
+            <a:off x="1005840" y="1828800"/>
+            <a:ext cx="4572000" cy="4114800"/>
           </a:xfrm>
           <a:prstGeom prst="rect">
             <a:avLst/>
@@ -6148,9 +6148,9 @@
               <a:spcAft>
                 <a:spcPts val="1200"/>
               </a:spcAft>
-              <a:defRPr sz="1600" b="1">
-                <a:solidFill>
-                  <a:srgbClr val="38BDF8"/>
+              <a:defRPr sz="1500" b="1">
+                <a:solidFill>
+                  <a:srgbClr val="1E3A8A"/>
                 </a:solidFill>
                 <a:latin typeface="Arial"/>
               </a:defRPr>
@@ -6164,15 +6164,15 @@
               <a:spcAft>
                 <a:spcPts val="800"/>
               </a:spcAft>
-              <a:defRPr sz="1250">
-                <a:solidFill>
-                  <a:srgbClr val="E2E8F0"/>
-                </a:solidFill>
-                <a:latin typeface="Arial"/>
-              </a:defRPr>
-            </a:pPr>
-            <a:r>
-              <a:t>• Token Web Efímero: El operador central envía un link único por WhatsApp o SMS. El coordinador hace clic y entra directo sin memorizar claves.</a:t>
+              <a:defRPr sz="1150">
+                <a:solidFill>
+                  <a:srgbClr val="334155"/>
+                </a:solidFill>
+                <a:latin typeface="Arial"/>
+              </a:defRPr>
+            </a:pPr>
+            <a:r>
+              <a:t>▪ Acceso Instantáneo por Token Web: enlaces temporales cifrados enviados directamente al coordinador; ingreso inmediato sin necesidad de memorizar contraseñas.</a:t>
             </a:r>
           </a:p>
           <a:p>
@@ -6180,15 +6180,15 @@
               <a:spcAft>
                 <a:spcPts val="800"/>
               </a:spcAft>
-              <a:defRPr sz="1250">
-                <a:solidFill>
-                  <a:srgbClr val="E2E8F0"/>
-                </a:solidFill>
-                <a:latin typeface="Arial"/>
-              </a:defRPr>
-            </a:pPr>
-            <a:r>
-              <a:t>• Compartimentación: El líder de Las Cocuizas solo ve Las Cocuizas; no tiene acceso al resto del estado.</a:t>
+              <a:defRPr sz="1150">
+                <a:solidFill>
+                  <a:srgbClr val="334155"/>
+                </a:solidFill>
+                <a:latin typeface="Arial"/>
+              </a:defRPr>
+            </a:pPr>
+            <a:r>
+              <a:t>▪ Compartimentación Territorial: cada enlace opera exclusivamente en su área asignada, garantizando estricta segmentación de responsabilidades.</a:t>
             </a:r>
           </a:p>
           <a:p>
@@ -6196,15 +6196,15 @@
               <a:spcAft>
                 <a:spcPts val="800"/>
               </a:spcAft>
-              <a:defRPr sz="1250">
-                <a:solidFill>
-                  <a:srgbClr val="E2E8F0"/>
-                </a:solidFill>
-                <a:latin typeface="Arial"/>
-              </a:defRPr>
-            </a:pPr>
-            <a:r>
-              <a:t>• Revocación en 1 Segundo: Si un coordinador es relevado, se desactiva su token desde la Sala de Mando sin afectar el resto del sistema.</a:t>
+              <a:defRPr sz="1150">
+                <a:solidFill>
+                  <a:srgbClr val="334155"/>
+                </a:solidFill>
+                <a:latin typeface="Arial"/>
+              </a:defRPr>
+            </a:pPr>
+            <a:r>
+              <a:t>▪ Revocación Inmediata de Credenciales: ante cualquier relevo de personal, la credencial se desactiva desde la consola central sin interrumpir el servicio.</a:t>
             </a:r>
           </a:p>
           <a:p>
@@ -6212,15 +6212,15 @@
               <a:spcAft>
                 <a:spcPts val="800"/>
               </a:spcAft>
-              <a:defRPr sz="1250">
-                <a:solidFill>
-                  <a:srgbClr val="E2E8F0"/>
-                </a:solidFill>
-                <a:latin typeface="Arial"/>
-              </a:defRPr>
-            </a:pPr>
-            <a:r>
-              <a:t>• Sin Apps Pesadas: Funciona 100% en el navegador de cualquier teléfono inteligente.</a:t>
+              <a:defRPr sz="1150">
+                <a:solidFill>
+                  <a:srgbClr val="334155"/>
+                </a:solidFill>
+                <a:latin typeface="Arial"/>
+              </a:defRPr>
+            </a:pPr>
+            <a:r>
+              <a:t>▪ Compatibilidad Universal: funciona directamente en navegadores móviles estándar sin requerir instalación de aplicaciones adicionales.</a:t>
             </a:r>
           </a:p>
         </p:txBody>
@@ -6233,18 +6233,18 @@
         </p:nvSpPr>
         <p:spPr>
           <a:xfrm>
-            <a:off x="6217920" y="1737360"/>
-            <a:ext cx="5212080" cy="4389120"/>
+            <a:off x="6217920" y="1645920"/>
+            <a:ext cx="5212080" cy="4572000"/>
           </a:xfrm>
           <a:prstGeom prst="roundRect">
             <a:avLst/>
           </a:prstGeom>
           <a:solidFill>
-            <a:srgbClr val="1E293B"/>
+            <a:srgbClr val="FFFFFF"/>
           </a:solidFill>
           <a:ln>
             <a:solidFill>
-              <a:srgbClr val="4ADE80"/>
+              <a:srgbClr val="1E3A8A"/>
             </a:solidFill>
           </a:ln>
         </p:spPr>
@@ -6278,8 +6278,8 @@
         </p:nvSpPr>
         <p:spPr>
           <a:xfrm>
-            <a:off x="6492240" y="1920240"/>
-            <a:ext cx="4663440" cy="4023360"/>
+            <a:off x="6492240" y="1828800"/>
+            <a:ext cx="4663440" cy="4114800"/>
           </a:xfrm>
           <a:prstGeom prst="rect">
             <a:avLst/>
@@ -6296,15 +6296,15 @@
               <a:spcAft>
                 <a:spcPts val="1200"/>
               </a:spcAft>
-              <a:defRPr sz="1600" b="1">
-                <a:solidFill>
-                  <a:srgbClr val="4ADE80"/>
-                </a:solidFill>
-                <a:latin typeface="Arial"/>
-              </a:defRPr>
-            </a:pPr>
-            <a:r>
-              <a:t>🛡️ Módulo 2: Censo Territorial 'Buzón Ciego'</a:t>
+              <a:defRPr sz="1500" b="1">
+                <a:solidFill>
+                  <a:srgbClr val="1E3A8A"/>
+                </a:solidFill>
+                <a:latin typeface="Arial"/>
+              </a:defRPr>
+            </a:pPr>
+            <a:r>
+              <a:t>🛡️ Módulo 2: Censo Territorial y Privacidad</a:t>
             </a:r>
           </a:p>
           <a:p>
@@ -6312,15 +6312,15 @@
               <a:spcAft>
                 <a:spcPts val="800"/>
               </a:spcAft>
-              <a:defRPr sz="1250">
-                <a:solidFill>
-                  <a:srgbClr val="E2E8F0"/>
-                </a:solidFill>
-                <a:latin typeface="Arial"/>
-              </a:defRPr>
-            </a:pPr>
-            <a:r>
-              <a:t>• Protección de la Ciudadanía: Por principio institucional, NO se solicitan nombres, cédulas ni números de teléfono de los vecinos.</a:t>
+              <a:defRPr sz="1150">
+                <a:solidFill>
+                  <a:srgbClr val="334155"/>
+                </a:solidFill>
+                <a:latin typeface="Arial"/>
+              </a:defRPr>
+            </a:pPr>
+            <a:r>
+              <a:t>▪ Protección de Identidad Ciudadana: por directriz institucional, el sistema no solicita nombres, cédulas ni números telefónicos de los vecinos censados.</a:t>
             </a:r>
           </a:p>
           <a:p>
@@ -6328,15 +6328,15 @@
               <a:spcAft>
                 <a:spcPts val="800"/>
               </a:spcAft>
-              <a:defRPr sz="1250">
-                <a:solidFill>
-                  <a:srgbClr val="E2E8F0"/>
-                </a:solidFill>
-                <a:latin typeface="Arial"/>
-              </a:defRPr>
-            </a:pPr>
-            <a:r>
-              <a:t>• Datos Numéricos y Servicios: Registra familias, viviendas, estimación de fuerza y fallas críticas de luz, agua y vialidad.</a:t>
+              <a:defRPr sz="1150">
+                <a:solidFill>
+                  <a:srgbClr val="334155"/>
+                </a:solidFill>
+                <a:latin typeface="Arial"/>
+              </a:defRPr>
+            </a:pPr>
+            <a:r>
+              <a:t>▪ Diagnóstico de Servicios Básicos: levantamiento riguroso de familias, viviendas y fallas críticas en suministro eléctrico, agua potable y vialidad.</a:t>
             </a:r>
           </a:p>
           <a:p>
@@ -6344,15 +6344,15 @@
               <a:spcAft>
                 <a:spcPts val="800"/>
               </a:spcAft>
-              <a:defRPr sz="1250">
-                <a:solidFill>
-                  <a:srgbClr val="E2E8F0"/>
-                </a:solidFill>
-                <a:latin typeface="Arial"/>
-              </a:defRPr>
-            </a:pPr>
-            <a:r>
-              <a:t>• Protocolo Zero-Byte Storage: Al pulsar 'Enviar', los datos viajan encriptados por HTTPS al servidor y la pantalla se reinicia a cero.</a:t>
+              <a:defRPr sz="1150">
+                <a:solidFill>
+                  <a:srgbClr val="334155"/>
+                </a:solidFill>
+                <a:latin typeface="Arial"/>
+              </a:defRPr>
+            </a:pPr>
+            <a:r>
+              <a:t>▪ Protocolo Zero-Byte Storage: al presionar enviar, los datos se transmiten al servidor central vía HTTPS y el formulario se restablece. No queda caché en el celular.</a:t>
             </a:r>
           </a:p>
           <a:p>
@@ -6360,15 +6360,15 @@
               <a:spcAft>
                 <a:spcPts val="800"/>
               </a:spcAft>
-              <a:defRPr sz="1250">
-                <a:solidFill>
-                  <a:srgbClr val="E2E8F0"/>
-                </a:solidFill>
-                <a:latin typeface="Arial"/>
-              </a:defRPr>
-            </a:pPr>
-            <a:r>
-              <a:t>• Dispositivo Limpio: En el teléfono no queda caché, historial ni borradores. Tranquilidad total ante revisiones en alcabalas.</a:t>
+              <a:defRPr sz="1150">
+                <a:solidFill>
+                  <a:srgbClr val="334155"/>
+                </a:solidFill>
+                <a:latin typeface="Arial"/>
+              </a:defRPr>
+            </a:pPr>
+            <a:r>
+              <a:t>▪ Tranquilidad Operativa: blindaje total del activista frente a revisiones no autorizadas de dispositivos en la vía pública.</a:t>
             </a:r>
           </a:p>
         </p:txBody>
@@ -6406,7 +6406,7 @@
             <a:avLst/>
           </a:prstGeom>
           <a:solidFill>
-            <a:srgbClr val="0F172A"/>
+            <a:srgbClr val="F8FAFC"/>
           </a:solidFill>
           <a:ln>
             <a:noFill/>
@@ -6443,7 +6443,7 @@
         <p:spPr>
           <a:xfrm>
             <a:off x="731520" y="365760"/>
-            <a:ext cx="9144000" cy="365760"/>
+            <a:ext cx="9144000" cy="320040"/>
           </a:xfrm>
           <a:prstGeom prst="rect">
             <a:avLst/>
@@ -6457,15 +6457,15 @@
           <a:lstStyle/>
           <a:p>
             <a:pPr>
-              <a:defRPr sz="1100" b="1">
-                <a:solidFill>
-                  <a:srgbClr val="38BDF8"/>
-                </a:solidFill>
-                <a:latin typeface="Arial"/>
-              </a:defRPr>
-            </a:pPr>
-            <a:r>
-              <a:t>MIGATO • EQUIPO TÉCNICO DE SISTEMAS</a:t>
+              <a:defRPr sz="1000" b="1">
+                <a:solidFill>
+                  <a:srgbClr val="0284C7"/>
+                </a:solidFill>
+                <a:latin typeface="Arial"/>
+              </a:defRPr>
+            </a:pPr>
+            <a:r>
+              <a:t>MIGATO • EQUIPO TÉCNICO DE SISTEMAS Y ARQUITECTURA DIGITAL</a:t>
             </a:r>
           </a:p>
         </p:txBody>
@@ -6478,8 +6478,8 @@
         </p:nvSpPr>
         <p:spPr>
           <a:xfrm>
-            <a:off x="731520" y="685800"/>
-            <a:ext cx="9601200" cy="731520"/>
+            <a:off x="731520" y="658368"/>
+            <a:ext cx="9601200" cy="685800"/>
           </a:xfrm>
           <a:prstGeom prst="rect">
             <a:avLst/>
@@ -6493,9 +6493,9 @@
           <a:lstStyle/>
           <a:p>
             <a:pPr>
-              <a:defRPr sz="2400" b="1">
-                <a:solidFill>
-                  <a:srgbClr val="FFFFFF"/>
+              <a:defRPr sz="2200" b="1">
+                <a:solidFill>
+                  <a:srgbClr val="0F172A"/>
                 </a:solidFill>
                 <a:latin typeface="Arial"/>
               </a:defRPr>
@@ -6523,7 +6523,7 @@
         <p:spPr>
           <a:xfrm>
             <a:off x="10789920" y="365760"/>
-            <a:ext cx="731520" cy="731520"/>
+            <a:ext cx="685800" cy="685800"/>
           </a:xfrm>
           <a:prstGeom prst="rect">
             <a:avLst/>
@@ -6538,14 +6538,14 @@
         </p:nvSpPr>
         <p:spPr>
           <a:xfrm>
-            <a:off x="731520" y="1463040"/>
+            <a:off x="731520" y="1371600"/>
             <a:ext cx="10728655" cy="18288"/>
           </a:xfrm>
           <a:prstGeom prst="rect">
             <a:avLst/>
           </a:prstGeom>
           <a:solidFill>
-            <a:srgbClr val="334155"/>
+            <a:srgbClr val="1E3A8A"/>
           </a:solidFill>
           <a:ln>
             <a:noFill/>
@@ -6581,18 +6581,18 @@
         </p:nvSpPr>
         <p:spPr>
           <a:xfrm>
-            <a:off x="731520" y="1737360"/>
-            <a:ext cx="3413455" cy="4389120"/>
+            <a:off x="731520" y="1645920"/>
+            <a:ext cx="3413455" cy="4572000"/>
           </a:xfrm>
           <a:prstGeom prst="roundRect">
             <a:avLst/>
           </a:prstGeom>
           <a:solidFill>
-            <a:srgbClr val="1E293B"/>
+            <a:srgbClr val="FFFFFF"/>
           </a:solidFill>
           <a:ln>
             <a:solidFill>
-              <a:srgbClr val="0284C7"/>
+              <a:srgbClr val="CBD5E1"/>
             </a:solidFill>
           </a:ln>
         </p:spPr>
@@ -6626,8 +6626,8 @@
         </p:nvSpPr>
         <p:spPr>
           <a:xfrm>
-            <a:off x="914400" y="1920240"/>
-            <a:ext cx="3047695" cy="4023360"/>
+            <a:off x="914400" y="1828800"/>
+            <a:ext cx="3047695" cy="4114800"/>
           </a:xfrm>
           <a:prstGeom prst="rect">
             <a:avLst/>
@@ -6644,15 +6644,15 @@
               <a:spcAft>
                 <a:spcPts val="1200"/>
               </a:spcAft>
-              <a:defRPr sz="1500" b="1">
-                <a:solidFill>
-                  <a:srgbClr val="0284C7"/>
-                </a:solidFill>
-                <a:latin typeface="Arial"/>
-              </a:defRPr>
-            </a:pPr>
-            <a:r>
-              <a:t>🗺️ 175 Centros y 361 Mesas</a:t>
+              <a:defRPr sz="1400" b="1">
+                <a:solidFill>
+                  <a:srgbClr val="1E3A8A"/>
+                </a:solidFill>
+                <a:latin typeface="Arial"/>
+              </a:defRPr>
+            </a:pPr>
+            <a:r>
+              <a:t>🗺️ Catálogo de Centros</a:t>
             </a:r>
           </a:p>
           <a:p>
@@ -6660,15 +6660,15 @@
               <a:spcAft>
                 <a:spcPts val="800"/>
               </a:spcAft>
-              <a:defRPr sz="1200">
-                <a:solidFill>
-                  <a:srgbClr val="E2E8F0"/>
-                </a:solidFill>
-                <a:latin typeface="Arial"/>
-              </a:defRPr>
-            </a:pPr>
-            <a:r>
-              <a:t>• Mapeo geoespacial completo del Municipio Maturín.</a:t>
+              <a:defRPr sz="1100">
+                <a:solidFill>
+                  <a:srgbClr val="334155"/>
+                </a:solidFill>
+                <a:latin typeface="Arial"/>
+              </a:defRPr>
+            </a:pPr>
+            <a:r>
+              <a:t>▪ Georreferenciación completa de 175 centros y 361 mesas electorales del Municipio Maturín.</a:t>
             </a:r>
           </a:p>
           <a:p>
@@ -6676,15 +6676,15 @@
               <a:spcAft>
                 <a:spcPts val="800"/>
               </a:spcAft>
-              <a:defRPr sz="1200">
-                <a:solidFill>
-                  <a:srgbClr val="E2E8F0"/>
-                </a:solidFill>
-                <a:latin typeface="Arial"/>
-              </a:defRPr>
-            </a:pPr>
-            <a:r>
-              <a:t>• Priorización matemática de los 40 centros que concentran más del 60% del padrón electoral.</a:t>
+              <a:defRPr sz="1100">
+                <a:solidFill>
+                  <a:srgbClr val="334155"/>
+                </a:solidFill>
+                <a:latin typeface="Arial"/>
+              </a:defRPr>
+            </a:pPr>
+            <a:r>
+              <a:t>▪ Identificación prioritaria de los 40 centros estratégicos que concentran más del 60% de los electores.</a:t>
             </a:r>
           </a:p>
           <a:p>
@@ -6692,15 +6692,15 @@
               <a:spcAft>
                 <a:spcPts val="800"/>
               </a:spcAft>
-              <a:defRPr sz="1200">
-                <a:solidFill>
-                  <a:srgbClr val="E2E8F0"/>
-                </a:solidFill>
-                <a:latin typeface="Arial"/>
-              </a:defRPr>
-            </a:pPr>
-            <a:r>
-              <a:t>• Ubicación satelital y rutas de acceso para movilización el día de la votación.</a:t>
+              <a:defRPr sz="1100">
+                <a:solidFill>
+                  <a:srgbClr val="334155"/>
+                </a:solidFill>
+                <a:latin typeface="Arial"/>
+              </a:defRPr>
+            </a:pPr>
+            <a:r>
+              <a:t>▪ Mapeo de accesos viales y distancias logísticas para optimizar la movilización.</a:t>
             </a:r>
           </a:p>
         </p:txBody>
@@ -6713,18 +6713,18 @@
         </p:nvSpPr>
         <p:spPr>
           <a:xfrm>
-            <a:off x="4389120" y="1737360"/>
-            <a:ext cx="3413455" cy="4389120"/>
+            <a:off x="4389120" y="1645920"/>
+            <a:ext cx="3413455" cy="4572000"/>
           </a:xfrm>
           <a:prstGeom prst="roundRect">
             <a:avLst/>
           </a:prstGeom>
           <a:solidFill>
-            <a:srgbClr val="1E293B"/>
+            <a:srgbClr val="FFFFFF"/>
           </a:solidFill>
           <a:ln>
             <a:solidFill>
-              <a:srgbClr val="38BDF8"/>
+              <a:srgbClr val="CBD5E1"/>
             </a:solidFill>
           </a:ln>
         </p:spPr>
@@ -6758,8 +6758,8 @@
         </p:nvSpPr>
         <p:spPr>
           <a:xfrm>
-            <a:off x="4572000" y="1920240"/>
-            <a:ext cx="3047695" cy="4023360"/>
+            <a:off x="4572000" y="1828800"/>
+            <a:ext cx="3047695" cy="4114800"/>
           </a:xfrm>
           <a:prstGeom prst="rect">
             <a:avLst/>
@@ -6776,15 +6776,15 @@
               <a:spcAft>
                 <a:spcPts val="1200"/>
               </a:spcAft>
-              <a:defRPr sz="1500" b="1">
-                <a:solidFill>
-                  <a:srgbClr val="38BDF8"/>
-                </a:solidFill>
-                <a:latin typeface="Arial"/>
-              </a:defRPr>
-            </a:pPr>
-            <a:r>
-              <a:t>👥 Organización de Testigos</a:t>
+              <a:defRPr sz="1400" b="1">
+                <a:solidFill>
+                  <a:srgbClr val="1E3A8A"/>
+                </a:solidFill>
+                <a:latin typeface="Arial"/>
+              </a:defRPr>
+            </a:pPr>
+            <a:r>
+              <a:t>👥 Estructura de Testigos</a:t>
             </a:r>
           </a:p>
           <a:p>
@@ -6792,15 +6792,15 @@
               <a:spcAft>
                 <a:spcPts val="800"/>
               </a:spcAft>
-              <a:defRPr sz="1200">
-                <a:solidFill>
-                  <a:srgbClr val="E2E8F0"/>
-                </a:solidFill>
-                <a:latin typeface="Arial"/>
-              </a:defRPr>
-            </a:pPr>
-            <a:r>
-              <a:t>• Registro ordenado del testigo principal y suplente por cada mesa electoral.</a:t>
+              <a:defRPr sz="1100">
+                <a:solidFill>
+                  <a:srgbClr val="334155"/>
+                </a:solidFill>
+                <a:latin typeface="Arial"/>
+              </a:defRPr>
+            </a:pPr>
+            <a:r>
+              <a:t>▪ Registro y acreditación organizada de testigos principales y suplentes por mesa electoral.</a:t>
             </a:r>
           </a:p>
           <a:p>
@@ -6808,15 +6808,15 @@
               <a:spcAft>
                 <a:spcPts val="800"/>
               </a:spcAft>
-              <a:defRPr sz="1200">
-                <a:solidFill>
-                  <a:srgbClr val="E2E8F0"/>
-                </a:solidFill>
-                <a:latin typeface="Arial"/>
-              </a:defRPr>
-            </a:pPr>
-            <a:r>
-              <a:t>• Segmentación de acompañamiento ciudadano a votantes de tercera edad y jóvenes.</a:t>
+              <a:defRPr sz="1100">
+                <a:solidFill>
+                  <a:srgbClr val="334155"/>
+                </a:solidFill>
+                <a:latin typeface="Arial"/>
+              </a:defRPr>
+            </a:pPr>
+            <a:r>
+              <a:t>▪ Segmentación de labores de asistencia ciudadana para adultos mayores y votantes jóvenes.</a:t>
             </a:r>
           </a:p>
           <a:p>
@@ -6824,15 +6824,15 @@
               <a:spcAft>
                 <a:spcPts val="800"/>
               </a:spcAft>
-              <a:defRPr sz="1200">
-                <a:solidFill>
-                  <a:srgbClr val="E2E8F0"/>
-                </a:solidFill>
-                <a:latin typeface="Arial"/>
-              </a:defRPr>
-            </a:pPr>
-            <a:r>
-              <a:t>• Reporte de incidencias y apertura de mesas en tiempo real.</a:t>
+              <a:defRPr sz="1100">
+                <a:solidFill>
+                  <a:srgbClr val="334155"/>
+                </a:solidFill>
+                <a:latin typeface="Arial"/>
+              </a:defRPr>
+            </a:pPr>
+            <a:r>
+              <a:t>▪ Canal de reporte de incidencias y apertura de mesas en comunicación con la Sala Situacional.</a:t>
             </a:r>
           </a:p>
         </p:txBody>
@@ -6845,18 +6845,18 @@
         </p:nvSpPr>
         <p:spPr>
           <a:xfrm>
-            <a:off x="8046720" y="1737360"/>
-            <a:ext cx="3413455" cy="4389120"/>
+            <a:off x="8046720" y="1645920"/>
+            <a:ext cx="3413455" cy="4572000"/>
           </a:xfrm>
           <a:prstGeom prst="roundRect">
             <a:avLst/>
           </a:prstGeom>
           <a:solidFill>
-            <a:srgbClr val="1E293B"/>
+            <a:srgbClr val="FFFFFF"/>
           </a:solidFill>
           <a:ln>
             <a:solidFill>
-              <a:srgbClr val="4ADE80"/>
+              <a:srgbClr val="CBD5E1"/>
             </a:solidFill>
           </a:ln>
         </p:spPr>
@@ -6890,8 +6890,8 @@
         </p:nvSpPr>
         <p:spPr>
           <a:xfrm>
-            <a:off x="8229600" y="1920240"/>
-            <a:ext cx="3047695" cy="4023360"/>
+            <a:off x="8229600" y="1828800"/>
+            <a:ext cx="3047695" cy="4114800"/>
           </a:xfrm>
           <a:prstGeom prst="rect">
             <a:avLst/>
@@ -6908,15 +6908,15 @@
               <a:spcAft>
                 <a:spcPts val="1200"/>
               </a:spcAft>
-              <a:defRPr sz="1500" b="1">
-                <a:solidFill>
-                  <a:srgbClr val="4ADE80"/>
-                </a:solidFill>
-                <a:latin typeface="Arial"/>
-              </a:defRPr>
-            </a:pPr>
-            <a:r>
-              <a:t>📸 Archivo de Actas y Código QR</a:t>
+              <a:defRPr sz="1400" b="1">
+                <a:solidFill>
+                  <a:srgbClr val="1E3A8A"/>
+                </a:solidFill>
+                <a:latin typeface="Arial"/>
+              </a:defRPr>
+            </a:pPr>
+            <a:r>
+              <a:t>📄 Archivo de Evidencia</a:t>
             </a:r>
           </a:p>
           <a:p>
@@ -6924,15 +6924,15 @@
               <a:spcAft>
                 <a:spcPts val="800"/>
               </a:spcAft>
-              <a:defRPr sz="1200">
-                <a:solidFill>
-                  <a:srgbClr val="E2E8F0"/>
-                </a:solidFill>
-                <a:latin typeface="Arial"/>
-              </a:defRPr>
-            </a:pPr>
-            <a:r>
-              <a:t>• Carga de resultados mesa por mesa por parte del testigo acreditado.</a:t>
+              <a:defRPr sz="1100">
+                <a:solidFill>
+                  <a:srgbClr val="334155"/>
+                </a:solidFill>
+                <a:latin typeface="Arial"/>
+              </a:defRPr>
+            </a:pPr>
+            <a:r>
+              <a:t>▪ Carga ordenada de resultados numéricos por mesa emitida por los testigos del partido.</a:t>
             </a:r>
           </a:p>
           <a:p>
@@ -6940,15 +6940,15 @@
               <a:spcAft>
                 <a:spcPts val="800"/>
               </a:spcAft>
-              <a:defRPr sz="1200">
-                <a:solidFill>
-                  <a:srgbClr val="E2E8F0"/>
-                </a:solidFill>
-                <a:latin typeface="Arial"/>
-              </a:defRPr>
-            </a:pPr>
-            <a:r>
-              <a:t>• Almacenamiento fotográfico en alta resolución del acta física y comprobante oficial.</a:t>
+              <a:defRPr sz="1100">
+                <a:solidFill>
+                  <a:srgbClr val="334155"/>
+                </a:solidFill>
+                <a:latin typeface="Arial"/>
+              </a:defRPr>
+            </a:pPr>
+            <a:r>
+              <a:t>▪ Almacenamiento de respaldo digital del acta física y comprobante oficial.</a:t>
             </a:r>
           </a:p>
           <a:p>
@@ -6956,15 +6956,15 @@
               <a:spcAft>
                 <a:spcPts val="800"/>
               </a:spcAft>
-              <a:defRPr sz="1200">
-                <a:solidFill>
-                  <a:srgbClr val="E2E8F0"/>
-                </a:solidFill>
-                <a:latin typeface="Arial"/>
-              </a:defRPr>
-            </a:pPr>
-            <a:r>
-              <a:t>• Captura del código QR del acta para cotejo y auditoría interna de la organización.</a:t>
+              <a:defRPr sz="1100">
+                <a:solidFill>
+                  <a:srgbClr val="334155"/>
+                </a:solidFill>
+                <a:latin typeface="Arial"/>
+              </a:defRPr>
+            </a:pPr>
+            <a:r>
+              <a:t>▪ Registro fotográfico del código QR para auditoría y cotejo interno de la organización.</a:t>
             </a:r>
           </a:p>
           <a:p>
@@ -6972,15 +6972,15 @@
               <a:spcAft>
                 <a:spcPts val="800"/>
               </a:spcAft>
-              <a:defRPr sz="1200">
-                <a:solidFill>
-                  <a:srgbClr val="E2E8F0"/>
-                </a:solidFill>
-                <a:latin typeface="Arial"/>
-              </a:defRPr>
-            </a:pPr>
-            <a:r>
-              <a:t>• Sin intervenir ni suplantar atribuciones del CNE.</a:t>
+              <a:defRPr sz="1100">
+                <a:solidFill>
+                  <a:srgbClr val="334155"/>
+                </a:solidFill>
+                <a:latin typeface="Arial"/>
+              </a:defRPr>
+            </a:pPr>
+            <a:r>
+              <a:t>▪ Sin intervenir ni suplantar las competencias del CNE.</a:t>
             </a:r>
           </a:p>
         </p:txBody>
@@ -7018,7 +7018,7 @@
             <a:avLst/>
           </a:prstGeom>
           <a:solidFill>
-            <a:srgbClr val="0F172A"/>
+            <a:srgbClr val="F8FAFC"/>
           </a:solidFill>
           <a:ln>
             <a:noFill/>
@@ -7055,7 +7055,7 @@
         <p:spPr>
           <a:xfrm>
             <a:off x="731520" y="365760"/>
-            <a:ext cx="9144000" cy="365760"/>
+            <a:ext cx="9144000" cy="320040"/>
           </a:xfrm>
           <a:prstGeom prst="rect">
             <a:avLst/>
@@ -7069,15 +7069,15 @@
           <a:lstStyle/>
           <a:p>
             <a:pPr>
-              <a:defRPr sz="1100" b="1">
-                <a:solidFill>
-                  <a:srgbClr val="38BDF8"/>
-                </a:solidFill>
-                <a:latin typeface="Arial"/>
-              </a:defRPr>
-            </a:pPr>
-            <a:r>
-              <a:t>MIGATO • EQUIPO TÉCNICO DE SISTEMAS</a:t>
+              <a:defRPr sz="1000" b="1">
+                <a:solidFill>
+                  <a:srgbClr val="0284C7"/>
+                </a:solidFill>
+                <a:latin typeface="Arial"/>
+              </a:defRPr>
+            </a:pPr>
+            <a:r>
+              <a:t>MIGATO • EQUIPO TÉCNICO DE SISTEMAS Y ARQUITECTURA DIGITAL</a:t>
             </a:r>
           </a:p>
         </p:txBody>
@@ -7090,8 +7090,8 @@
         </p:nvSpPr>
         <p:spPr>
           <a:xfrm>
-            <a:off x="731520" y="685800"/>
-            <a:ext cx="9601200" cy="731520"/>
+            <a:off x="731520" y="658368"/>
+            <a:ext cx="9601200" cy="685800"/>
           </a:xfrm>
           <a:prstGeom prst="rect">
             <a:avLst/>
@@ -7105,15 +7105,15 @@
           <a:lstStyle/>
           <a:p>
             <a:pPr>
-              <a:defRPr sz="2400" b="1">
-                <a:solidFill>
-                  <a:srgbClr val="FFFFFF"/>
-                </a:solidFill>
-                <a:latin typeface="Arial"/>
-              </a:defRPr>
-            </a:pPr>
-            <a:r>
-              <a:t>Módulos 4 y 5: Cartografía Tridimensional y Red Asistencial de Salud</a:t>
+              <a:defRPr sz="2200" b="1">
+                <a:solidFill>
+                  <a:srgbClr val="0F172A"/>
+                </a:solidFill>
+                <a:latin typeface="Arial"/>
+              </a:defRPr>
+            </a:pPr>
+            <a:r>
+              <a:t>Módulos 4 y 5: Cartografía Tridimensional y Auditoría Asistencial</a:t>
             </a:r>
           </a:p>
         </p:txBody>
@@ -7135,7 +7135,7 @@
         <p:spPr>
           <a:xfrm>
             <a:off x="10789920" y="365760"/>
-            <a:ext cx="731520" cy="731520"/>
+            <a:ext cx="685800" cy="685800"/>
           </a:xfrm>
           <a:prstGeom prst="rect">
             <a:avLst/>
@@ -7150,14 +7150,14 @@
         </p:nvSpPr>
         <p:spPr>
           <a:xfrm>
-            <a:off x="731520" y="1463040"/>
+            <a:off x="731520" y="1371600"/>
             <a:ext cx="10728655" cy="18288"/>
           </a:xfrm>
           <a:prstGeom prst="rect">
             <a:avLst/>
           </a:prstGeom>
           <a:solidFill>
-            <a:srgbClr val="334155"/>
+            <a:srgbClr val="1E3A8A"/>
           </a:solidFill>
           <a:ln>
             <a:noFill/>
@@ -7193,18 +7193,18 @@
         </p:nvSpPr>
         <p:spPr>
           <a:xfrm>
-            <a:off x="731520" y="1737360"/>
-            <a:ext cx="5120640" cy="4389120"/>
+            <a:off x="731520" y="1645920"/>
+            <a:ext cx="5120640" cy="4572000"/>
           </a:xfrm>
           <a:prstGeom prst="roundRect">
             <a:avLst/>
           </a:prstGeom>
           <a:solidFill>
-            <a:srgbClr val="1E293B"/>
+            <a:srgbClr val="FFFFFF"/>
           </a:solidFill>
           <a:ln>
             <a:solidFill>
-              <a:srgbClr val="0284C7"/>
+              <a:srgbClr val="CBD5E1"/>
             </a:solidFill>
           </a:ln>
         </p:spPr>
@@ -7238,8 +7238,8 @@
         </p:nvSpPr>
         <p:spPr>
           <a:xfrm>
-            <a:off x="1005840" y="1920240"/>
-            <a:ext cx="4572000" cy="4023360"/>
+            <a:off x="1005840" y="1828800"/>
+            <a:ext cx="4572000" cy="4114800"/>
           </a:xfrm>
           <a:prstGeom prst="rect">
             <a:avLst/>
@@ -7256,15 +7256,15 @@
               <a:spcAft>
                 <a:spcPts val="1200"/>
               </a:spcAft>
-              <a:defRPr sz="1600" b="1">
-                <a:solidFill>
-                  <a:srgbClr val="38BDF8"/>
-                </a:solidFill>
-                <a:latin typeface="Arial"/>
-              </a:defRPr>
-            </a:pPr>
-            <a:r>
-              <a:t>🌐 Módulo 4: Cartografía 3D de Infraestructura</a:t>
+              <a:defRPr sz="1450" b="1">
+                <a:solidFill>
+                  <a:srgbClr val="1E3A8A"/>
+                </a:solidFill>
+                <a:latin typeface="Arial"/>
+              </a:defRPr>
+            </a:pPr>
+            <a:r>
+              <a:t>🌐 Cartografía 3D de Infraestructura (/earth-monagas/)</a:t>
             </a:r>
           </a:p>
           <a:p>
@@ -7272,15 +7272,15 @@
               <a:spcAft>
                 <a:spcPts val="800"/>
               </a:spcAft>
-              <a:defRPr sz="1250">
-                <a:solidFill>
-                  <a:srgbClr val="E2E8F0"/>
-                </a:solidFill>
-                <a:latin typeface="Arial"/>
-              </a:defRPr>
-            </a:pPr>
-            <a:r>
-              <a:t>• Visualización Geoespacial 3D: Elevaciones topográficas, vialidad, distribución comunitaria y servicios críticos en Monagas.</a:t>
+              <a:defRPr sz="1150">
+                <a:solidFill>
+                  <a:srgbClr val="334155"/>
+                </a:solidFill>
+                <a:latin typeface="Arial"/>
+              </a:defRPr>
+            </a:pPr>
+            <a:r>
+              <a:t>▪ Análisis Geoespacial Interactivo: representación tridimensional de relieve, vialidad, comunidades y equipamiento de servicios en la entidad.</a:t>
             </a:r>
           </a:p>
           <a:p>
@@ -7288,15 +7288,15 @@
               <a:spcAft>
                 <a:spcPts val="800"/>
               </a:spcAft>
-              <a:defRPr sz="1250">
-                <a:solidFill>
-                  <a:srgbClr val="E2E8F0"/>
-                </a:solidFill>
-                <a:latin typeface="Arial"/>
-              </a:defRPr>
-            </a:pPr>
-            <a:r>
-              <a:t>• Filtro de Focalización Territorial: Aplica una atenuación suave sobre la periferia para concentrar la atención en la parroquia o sector bajo análisis.</a:t>
+              <a:defRPr sz="1150">
+                <a:solidFill>
+                  <a:srgbClr val="334155"/>
+                </a:solidFill>
+                <a:latin typeface="Arial"/>
+              </a:defRPr>
+            </a:pPr>
+            <a:r>
+              <a:t>▪ Herramienta de Focalización Territorial: filtro visual que atenúa suavemente las zonas periféricas para concentrar el análisis en la parroquia de interés.</a:t>
             </a:r>
           </a:p>
           <a:p>
@@ -7304,15 +7304,15 @@
               <a:spcAft>
                 <a:spcPts val="800"/>
               </a:spcAft>
-              <a:defRPr sz="1250">
-                <a:solidFill>
-                  <a:srgbClr val="E2E8F0"/>
-                </a:solidFill>
-                <a:latin typeface="Arial"/>
-              </a:defRPr>
-            </a:pPr>
-            <a:r>
-              <a:t>• Planificación Táctica y Logística: Cálculo de distancias reales, tiempos de traslado y rutas óptimas para los equipos de campo.</a:t>
+              <a:defRPr sz="1150">
+                <a:solidFill>
+                  <a:srgbClr val="334155"/>
+                </a:solidFill>
+                <a:latin typeface="Arial"/>
+              </a:defRPr>
+            </a:pPr>
+            <a:r>
+              <a:t>▪ Planificación de Rutas y Despliegue: medición precisa de distancias y estimación de tiempos de traslado para jornadas institucionales de trabajo.</a:t>
             </a:r>
           </a:p>
           <a:p>
@@ -7320,15 +7320,15 @@
               <a:spcAft>
                 <a:spcPts val="800"/>
               </a:spcAft>
-              <a:defRPr sz="1250">
-                <a:solidFill>
-                  <a:srgbClr val="E2E8F0"/>
-                </a:solidFill>
-                <a:latin typeface="Arial"/>
-              </a:defRPr>
-            </a:pPr>
-            <a:r>
-              <a:t>• Uso en Sala de Mando: Ideal para proyectar en pantallas grandes durante reuniones estratégicas de la dirección.</a:t>
+              <a:defRPr sz="1150">
+                <a:solidFill>
+                  <a:srgbClr val="334155"/>
+                </a:solidFill>
+                <a:latin typeface="Arial"/>
+              </a:defRPr>
+            </a:pPr>
+            <a:r>
+              <a:t>▪ Optimizado para Sala de Mando: interfaz adaptada para proyección en pantallas corporativas de alta definición.</a:t>
             </a:r>
           </a:p>
         </p:txBody>
@@ -7341,18 +7341,18 @@
         </p:nvSpPr>
         <p:spPr>
           <a:xfrm>
-            <a:off x="6217920" y="1737360"/>
-            <a:ext cx="5212080" cy="4389120"/>
+            <a:off x="6217920" y="1645920"/>
+            <a:ext cx="5212080" cy="4572000"/>
           </a:xfrm>
           <a:prstGeom prst="roundRect">
             <a:avLst/>
           </a:prstGeom>
           <a:solidFill>
-            <a:srgbClr val="1E293B"/>
+            <a:srgbClr val="FFFFFF"/>
           </a:solidFill>
           <a:ln>
             <a:solidFill>
-              <a:srgbClr val="38BDF8"/>
+              <a:srgbClr val="1E3A8A"/>
             </a:solidFill>
           </a:ln>
         </p:spPr>
@@ -7386,8 +7386,8 @@
         </p:nvSpPr>
         <p:spPr>
           <a:xfrm>
-            <a:off x="6492240" y="1920240"/>
-            <a:ext cx="4663440" cy="4023360"/>
+            <a:off x="6492240" y="1828800"/>
+            <a:ext cx="4663440" cy="4114800"/>
           </a:xfrm>
           <a:prstGeom prst="rect">
             <a:avLst/>
@@ -7404,15 +7404,15 @@
               <a:spcAft>
                 <a:spcPts val="1200"/>
               </a:spcAft>
-              <a:defRPr sz="1600" b="1">
-                <a:solidFill>
-                  <a:srgbClr val="0284C7"/>
-                </a:solidFill>
-                <a:latin typeface="Arial"/>
-              </a:defRPr>
-            </a:pPr>
-            <a:r>
-              <a:t>🏥 Módulo 5: Diagnóstico y Red de Salud</a:t>
+              <a:defRPr sz="1450" b="1">
+                <a:solidFill>
+                  <a:srgbClr val="1E3A8A"/>
+                </a:solidFill>
+                <a:latin typeface="Arial"/>
+              </a:defRPr>
+            </a:pPr>
+            <a:r>
+              <a:t>🏥 Diagnóstico de la Red de Salud (/salud-monagas/)</a:t>
             </a:r>
           </a:p>
           <a:p>
@@ -7420,15 +7420,15 @@
               <a:spcAft>
                 <a:spcPts val="800"/>
               </a:spcAft>
-              <a:defRPr sz="1250">
-                <a:solidFill>
-                  <a:srgbClr val="E2E8F0"/>
-                </a:solidFill>
-                <a:latin typeface="Arial"/>
-              </a:defRPr>
-            </a:pPr>
-            <a:r>
-              <a:t>• Censo Sanitario Exhaustivo: Monitoreo técnico de 84 centros asistenciales (Hospital Central, ambulatorios urbanos, rurales y CDI).</a:t>
+              <a:defRPr sz="1150">
+                <a:solidFill>
+                  <a:srgbClr val="334155"/>
+                </a:solidFill>
+                <a:latin typeface="Arial"/>
+              </a:defRPr>
+            </a:pPr>
+            <a:r>
+              <a:t>▪ Supervisión Integral de 84 Centros: monitoreo técnico de hospitales universitarios, ambulatorios urbanos, rurales y centros integrales.</a:t>
             </a:r>
           </a:p>
           <a:p>
@@ -7436,15 +7436,15 @@
               <a:spcAft>
                 <a:spcPts val="800"/>
               </a:spcAft>
-              <a:defRPr sz="1250">
-                <a:solidFill>
-                  <a:srgbClr val="E2E8F0"/>
-                </a:solidFill>
-                <a:latin typeface="Arial"/>
-              </a:defRPr>
-            </a:pPr>
-            <a:r>
-              <a:t>• Servicios Críticos: Estado real de plantas eléctricas de emergencia, suministro de agua por tubería, quirófanos y salas de parto.</a:t>
+              <a:defRPr sz="1150">
+                <a:solidFill>
+                  <a:srgbClr val="334155"/>
+                </a:solidFill>
+                <a:latin typeface="Arial"/>
+              </a:defRPr>
+            </a:pPr>
+            <a:r>
+              <a:t>▪ Estado de Servicios Críticos: operatividad de generadores eléctricos de emergencia, suministro continuo de agua y salas quirúrgicas.</a:t>
             </a:r>
           </a:p>
           <a:p>
@@ -7452,15 +7452,15 @@
               <a:spcAft>
                 <a:spcPts val="800"/>
               </a:spcAft>
-              <a:defRPr sz="1250">
-                <a:solidFill>
-                  <a:srgbClr val="E2E8F0"/>
-                </a:solidFill>
-                <a:latin typeface="Arial"/>
-              </a:defRPr>
-            </a:pPr>
-            <a:r>
-              <a:t>• Red de Derivación Médica: Registro de rutas de traslado de pacientes cuando un ambulatorio no tiene capacidad de resolución.</a:t>
+              <a:defRPr sz="1150">
+                <a:solidFill>
+                  <a:srgbClr val="334155"/>
+                </a:solidFill>
+                <a:latin typeface="Arial"/>
+              </a:defRPr>
+            </a:pPr>
+            <a:r>
+              <a:t>▪ Red de Referencia y Traslado: registro de las rutas de derivación de pacientes cuando la capacidad de resolución local se ve superada.</a:t>
             </a:r>
           </a:p>
           <a:p>
@@ -7468,15 +7468,15 @@
               <a:spcAft>
                 <a:spcPts val="800"/>
               </a:spcAft>
-              <a:defRPr sz="1250">
-                <a:solidFill>
-                  <a:srgbClr val="E2E8F0"/>
-                </a:solidFill>
-                <a:latin typeface="Arial"/>
-              </a:defRPr>
-            </a:pPr>
-            <a:r>
-              <a:t>• Base para el Plan de Gobierno: Sustento con datos reales de ingeniería para proponer soluciones hospitalarias concretas ante la opinión pública.</a:t>
+              <a:defRPr sz="1150">
+                <a:solidFill>
+                  <a:srgbClr val="334155"/>
+                </a:solidFill>
+                <a:latin typeface="Arial"/>
+              </a:defRPr>
+            </a:pPr>
+            <a:r>
+              <a:t>▪ Fundamento para Políticas Públicas: base de datos auditable que sustenta propuestas de rehabilitación sanitaria con criterios de ingeniería.</a:t>
             </a:r>
           </a:p>
         </p:txBody>
@@ -7514,7 +7514,7 @@
             <a:avLst/>
           </a:prstGeom>
           <a:solidFill>
-            <a:srgbClr val="0F172A"/>
+            <a:srgbClr val="F8FAFC"/>
           </a:solidFill>
           <a:ln>
             <a:noFill/>
@@ -7551,7 +7551,7 @@
         <p:spPr>
           <a:xfrm>
             <a:off x="731520" y="365760"/>
-            <a:ext cx="9144000" cy="365760"/>
+            <a:ext cx="9144000" cy="320040"/>
           </a:xfrm>
           <a:prstGeom prst="rect">
             <a:avLst/>
@@ -7565,15 +7565,15 @@
           <a:lstStyle/>
           <a:p>
             <a:pPr>
-              <a:defRPr sz="1100" b="1">
-                <a:solidFill>
-                  <a:srgbClr val="38BDF8"/>
-                </a:solidFill>
-                <a:latin typeface="Arial"/>
-              </a:defRPr>
-            </a:pPr>
-            <a:r>
-              <a:t>MIGATO • EQUIPO TÉCNICO DE SISTEMAS</a:t>
+              <a:defRPr sz="1000" b="1">
+                <a:solidFill>
+                  <a:srgbClr val="0284C7"/>
+                </a:solidFill>
+                <a:latin typeface="Arial"/>
+              </a:defRPr>
+            </a:pPr>
+            <a:r>
+              <a:t>MIGATO • EQUIPO TÉCNICO DE SISTEMAS Y ARQUITECTURA DIGITAL</a:t>
             </a:r>
           </a:p>
         </p:txBody>
@@ -7586,8 +7586,8 @@
         </p:nvSpPr>
         <p:spPr>
           <a:xfrm>
-            <a:off x="731520" y="685800"/>
-            <a:ext cx="9601200" cy="731520"/>
+            <a:off x="731520" y="658368"/>
+            <a:ext cx="9601200" cy="685800"/>
           </a:xfrm>
           <a:prstGeom prst="rect">
             <a:avLst/>
@@ -7601,15 +7601,15 @@
           <a:lstStyle/>
           <a:p>
             <a:pPr>
-              <a:defRPr sz="2400" b="1">
-                <a:solidFill>
-                  <a:srgbClr val="FFFFFF"/>
-                </a:solidFill>
-                <a:latin typeface="Arial"/>
-              </a:defRPr>
-            </a:pPr>
-            <a:r>
-              <a:t>Seguridad y Blindaje Informático: Soberanía de los Datos</a:t>
+              <a:defRPr sz="2200" b="1">
+                <a:solidFill>
+                  <a:srgbClr val="0F172A"/>
+                </a:solidFill>
+                <a:latin typeface="Arial"/>
+              </a:defRPr>
+            </a:pPr>
+            <a:r>
+              <a:t>Seguridad de la Información y Servidor Cloud VPS Dedicado</a:t>
             </a:r>
           </a:p>
         </p:txBody>
@@ -7631,7 +7631,7 @@
         <p:spPr>
           <a:xfrm>
             <a:off x="10789920" y="365760"/>
-            <a:ext cx="731520" cy="731520"/>
+            <a:ext cx="685800" cy="685800"/>
           </a:xfrm>
           <a:prstGeom prst="rect">
             <a:avLst/>
@@ -7646,14 +7646,14 @@
         </p:nvSpPr>
         <p:spPr>
           <a:xfrm>
-            <a:off x="731520" y="1463040"/>
+            <a:off x="731520" y="1371600"/>
             <a:ext cx="10728655" cy="18288"/>
           </a:xfrm>
           <a:prstGeom prst="rect">
             <a:avLst/>
           </a:prstGeom>
           <a:solidFill>
-            <a:srgbClr val="334155"/>
+            <a:srgbClr val="1E3A8A"/>
           </a:solidFill>
           <a:ln>
             <a:noFill/>
@@ -7689,18 +7689,18 @@
         </p:nvSpPr>
         <p:spPr>
           <a:xfrm>
-            <a:off x="731520" y="1737360"/>
-            <a:ext cx="5212080" cy="2011680"/>
+            <a:off x="731520" y="1645920"/>
+            <a:ext cx="5212080" cy="2057400"/>
           </a:xfrm>
           <a:prstGeom prst="roundRect">
             <a:avLst/>
           </a:prstGeom>
           <a:solidFill>
-            <a:srgbClr val="1E293B"/>
+            <a:srgbClr val="FFFFFF"/>
           </a:solidFill>
           <a:ln>
             <a:solidFill>
-              <a:srgbClr val="0284C7"/>
+              <a:srgbClr val="CBD5E1"/>
             </a:solidFill>
           </a:ln>
         </p:spPr>
@@ -7734,8 +7734,8 @@
         </p:nvSpPr>
         <p:spPr>
           <a:xfrm>
-            <a:off x="960120" y="1920240"/>
-            <a:ext cx="4754880" cy="1645920"/>
+            <a:off x="960120" y="1828800"/>
+            <a:ext cx="4754880" cy="1691640"/>
           </a:xfrm>
           <a:prstGeom prst="rect">
             <a:avLst/>
@@ -7752,28 +7752,28 @@
               <a:spcAft>
                 <a:spcPts val="600"/>
               </a:spcAft>
-              <a:defRPr sz="1500" b="1">
-                <a:solidFill>
-                  <a:srgbClr val="0284C7"/>
-                </a:solidFill>
-                <a:latin typeface="Arial"/>
-              </a:defRPr>
-            </a:pPr>
-            <a:r>
-              <a:t>🔒 Cifrado SSL/TLS 256 bits</a:t>
+              <a:defRPr sz="1400" b="1">
+                <a:solidFill>
+                  <a:srgbClr val="1E3A8A"/>
+                </a:solidFill>
+                <a:latin typeface="Arial"/>
+              </a:defRPr>
+            </a:pPr>
+            <a:r>
+              <a:t>🔒 Cifrado SSL/TLS de 256 Bits</a:t>
             </a:r>
           </a:p>
           <a:p>
             <a:pPr>
-              <a:defRPr sz="1200">
-                <a:solidFill>
-                  <a:srgbClr val="E2E8F0"/>
-                </a:solidFill>
-                <a:latin typeface="Arial"/>
-              </a:defRPr>
-            </a:pPr>
-            <a:r>
-              <a:t>Toda la comunicación entre los teléfonos de los coordinadores y el servidor viaja encriptada. Es imposible interceptar la información en redes móviles o puntos WiFi.</a:t>
+              <a:defRPr sz="1150">
+                <a:solidFill>
+                  <a:srgbClr val="334155"/>
+                </a:solidFill>
+                <a:latin typeface="Arial"/>
+              </a:defRPr>
+            </a:pPr>
+            <a:r>
+              <a:t>Encriptación completa de extremo a extremo en todas las sesiones web, impidiendo la intercepción de tráfico o fuga de datos en redes públicas o conexiones móviles.</a:t>
             </a:r>
           </a:p>
         </p:txBody>
@@ -7786,18 +7786,18 @@
         </p:nvSpPr>
         <p:spPr>
           <a:xfrm>
-            <a:off x="6217920" y="1737360"/>
-            <a:ext cx="5212080" cy="2011680"/>
+            <a:off x="6217920" y="1645920"/>
+            <a:ext cx="5212080" cy="2057400"/>
           </a:xfrm>
           <a:prstGeom prst="roundRect">
             <a:avLst/>
           </a:prstGeom>
           <a:solidFill>
-            <a:srgbClr val="1E293B"/>
+            <a:srgbClr val="FFFFFF"/>
           </a:solidFill>
           <a:ln>
             <a:solidFill>
-              <a:srgbClr val="38BDF8"/>
+              <a:srgbClr val="CBD5E1"/>
             </a:solidFill>
           </a:ln>
         </p:spPr>
@@ -7831,8 +7831,8 @@
         </p:nvSpPr>
         <p:spPr>
           <a:xfrm>
-            <a:off x="6446520" y="1920240"/>
-            <a:ext cx="4754880" cy="1645920"/>
+            <a:off x="6446520" y="1828800"/>
+            <a:ext cx="4754880" cy="1691640"/>
           </a:xfrm>
           <a:prstGeom prst="rect">
             <a:avLst/>
@@ -7849,9 +7849,9 @@
               <a:spcAft>
                 <a:spcPts val="600"/>
               </a:spcAft>
-              <a:defRPr sz="1500" b="1">
-                <a:solidFill>
-                  <a:srgbClr val="38BDF8"/>
+              <a:defRPr sz="1400" b="1">
+                <a:solidFill>
+                  <a:srgbClr val="1E3A8A"/>
                 </a:solidFill>
                 <a:latin typeface="Arial"/>
               </a:defRPr>
@@ -7862,15 +7862,15 @@
           </a:p>
           <a:p>
             <a:pPr>
-              <a:defRPr sz="1200">
-                <a:solidFill>
-                  <a:srgbClr val="E2E8F0"/>
-                </a:solidFill>
-                <a:latin typeface="Arial"/>
-              </a:defRPr>
-            </a:pPr>
-            <a:r>
-              <a:t>Cierre estricto de puertos, cortafuegos iptables, protección Fail2ban contra intentos de acceso forzado y acceso al panel restringido a IPs autorizadas.</a:t>
+              <a:defRPr sz="1150">
+                <a:solidFill>
+                  <a:srgbClr val="334155"/>
+                </a:solidFill>
+                <a:latin typeface="Arial"/>
+              </a:defRPr>
+            </a:pPr>
+            <a:r>
+              <a:t>Cierre estricto de puertos no esenciales, filtrado de conexiones mediante reglas iptables y mitigación automatizada de intentos de intrusión repetitivos (Fail2ban).</a:t>
             </a:r>
           </a:p>
         </p:txBody>
@@ -7883,18 +7883,18 @@
         </p:nvSpPr>
         <p:spPr>
           <a:xfrm>
-            <a:off x="731520" y="4023360"/>
-            <a:ext cx="5212080" cy="2011680"/>
+            <a:off x="731520" y="3931920"/>
+            <a:ext cx="5212080" cy="2057400"/>
           </a:xfrm>
           <a:prstGeom prst="roundRect">
             <a:avLst/>
           </a:prstGeom>
           <a:solidFill>
-            <a:srgbClr val="1E293B"/>
+            <a:srgbClr val="FFFFFF"/>
           </a:solidFill>
           <a:ln>
             <a:solidFill>
-              <a:srgbClr val="4ADE80"/>
+              <a:srgbClr val="CBD5E1"/>
             </a:solidFill>
           </a:ln>
         </p:spPr>
@@ -7928,8 +7928,8 @@
         </p:nvSpPr>
         <p:spPr>
           <a:xfrm>
-            <a:off x="960120" y="4206240"/>
-            <a:ext cx="4754880" cy="1645920"/>
+            <a:off x="960120" y="4114800"/>
+            <a:ext cx="4754880" cy="1691640"/>
           </a:xfrm>
           <a:prstGeom prst="rect">
             <a:avLst/>
@@ -7946,9 +7946,9 @@
               <a:spcAft>
                 <a:spcPts val="600"/>
               </a:spcAft>
-              <a:defRPr sz="1500" b="1">
-                <a:solidFill>
-                  <a:srgbClr val="4ADE80"/>
+              <a:defRPr sz="1400" b="1">
+                <a:solidFill>
+                  <a:srgbClr val="1E3A8A"/>
                 </a:solidFill>
                 <a:latin typeface="Arial"/>
               </a:defRPr>
@@ -7959,15 +7959,15 @@
           </a:p>
           <a:p>
             <a:pPr>
-              <a:defRPr sz="1200">
-                <a:solidFill>
-                  <a:srgbClr val="E2E8F0"/>
-                </a:solidFill>
-                <a:latin typeface="Arial"/>
-              </a:defRPr>
-            </a:pPr>
-            <a:r>
-              <a:t>Simulaciones de alta carga para garantizar que el servidor responda en menos de 1 segundo incluso durante las horas más intensas del día electoral.</a:t>
+              <a:defRPr sz="1150">
+                <a:solidFill>
+                  <a:srgbClr val="334155"/>
+                </a:solidFill>
+                <a:latin typeface="Arial"/>
+              </a:defRPr>
+            </a:pPr>
+            <a:r>
+              <a:t>Simulaciones de alta demanda de tráfico para certificar que el servidor mantenga tiempos de respuesta óptimos (menores a 1 segundo) durante jornadas intensas de carga.</a:t>
             </a:r>
           </a:p>
         </p:txBody>
@@ -7980,18 +7980,18 @@
         </p:nvSpPr>
         <p:spPr>
           <a:xfrm>
-            <a:off x="6217920" y="4023360"/>
-            <a:ext cx="5212080" cy="2011680"/>
+            <a:off x="6217920" y="3931920"/>
+            <a:ext cx="5212080" cy="2057400"/>
           </a:xfrm>
           <a:prstGeom prst="roundRect">
             <a:avLst/>
           </a:prstGeom>
           <a:solidFill>
-            <a:srgbClr val="1E293B"/>
+            <a:srgbClr val="FFFFFF"/>
           </a:solidFill>
           <a:ln>
             <a:solidFill>
-              <a:srgbClr val="E2E8F0"/>
+              <a:srgbClr val="CBD5E1"/>
             </a:solidFill>
           </a:ln>
         </p:spPr>
@@ -8025,8 +8025,8 @@
         </p:nvSpPr>
         <p:spPr>
           <a:xfrm>
-            <a:off x="6446520" y="4206240"/>
-            <a:ext cx="4754880" cy="1645920"/>
+            <a:off x="6446520" y="4114800"/>
+            <a:ext cx="4754880" cy="1691640"/>
           </a:xfrm>
           <a:prstGeom prst="rect">
             <a:avLst/>
@@ -8043,9 +8043,9 @@
               <a:spcAft>
                 <a:spcPts val="600"/>
               </a:spcAft>
-              <a:defRPr sz="1500" b="1">
-                <a:solidFill>
-                  <a:srgbClr val="E2E8F0"/>
+              <a:defRPr sz="1400" b="1">
+                <a:solidFill>
+                  <a:srgbClr val="1E3A8A"/>
                 </a:solidFill>
                 <a:latin typeface="Arial"/>
               </a:defRPr>
@@ -8056,15 +8056,15 @@
           </a:p>
           <a:p>
             <a:pPr>
-              <a:defRPr sz="1200">
-                <a:solidFill>
-                  <a:srgbClr val="E2E8F0"/>
-                </a:solidFill>
-                <a:latin typeface="Arial"/>
-              </a:defRPr>
-            </a:pPr>
-            <a:r>
-              <a:t>Copias de seguridad encriptadas periódicas para evitar cualquier pérdida de información ante fallas técnicas imprevistas.</a:t>
+              <a:defRPr sz="1150">
+                <a:solidFill>
+                  <a:srgbClr val="334155"/>
+                </a:solidFill>
+                <a:latin typeface="Arial"/>
+              </a:defRPr>
+            </a:pPr>
+            <a:r>
+              <a:t>Generación periódica de copias de seguridad encriptadas fuera del servidor principal para asegurar la continuidad del servicio ante cualquier eventualidad técnica.</a:t>
             </a:r>
           </a:p>
         </p:txBody>
@@ -8102,7 +8102,7 @@
             <a:avLst/>
           </a:prstGeom>
           <a:solidFill>
-            <a:srgbClr val="0F172A"/>
+            <a:srgbClr val="F8FAFC"/>
           </a:solidFill>
           <a:ln>
             <a:noFill/>
@@ -8139,7 +8139,7 @@
         <p:spPr>
           <a:xfrm>
             <a:off x="731520" y="365760"/>
-            <a:ext cx="9144000" cy="365760"/>
+            <a:ext cx="9144000" cy="320040"/>
           </a:xfrm>
           <a:prstGeom prst="rect">
             <a:avLst/>
@@ -8153,15 +8153,15 @@
           <a:lstStyle/>
           <a:p>
             <a:pPr>
-              <a:defRPr sz="1100" b="1">
-                <a:solidFill>
-                  <a:srgbClr val="38BDF8"/>
-                </a:solidFill>
-                <a:latin typeface="Arial"/>
-              </a:defRPr>
-            </a:pPr>
-            <a:r>
-              <a:t>MIGATO • EQUIPO TÉCNICO DE SISTEMAS</a:t>
+              <a:defRPr sz="1000" b="1">
+                <a:solidFill>
+                  <a:srgbClr val="0284C7"/>
+                </a:solidFill>
+                <a:latin typeface="Arial"/>
+              </a:defRPr>
+            </a:pPr>
+            <a:r>
+              <a:t>MIGATO • EQUIPO TÉCNICO DE SISTEMAS Y ARQUITECTURA DIGITAL</a:t>
             </a:r>
           </a:p>
         </p:txBody>
@@ -8174,8 +8174,8 @@
         </p:nvSpPr>
         <p:spPr>
           <a:xfrm>
-            <a:off x="731520" y="685800"/>
-            <a:ext cx="9601200" cy="731520"/>
+            <a:off x="731520" y="658368"/>
+            <a:ext cx="9601200" cy="685800"/>
           </a:xfrm>
           <a:prstGeom prst="rect">
             <a:avLst/>
@@ -8189,15 +8189,15 @@
           <a:lstStyle/>
           <a:p>
             <a:pPr>
-              <a:defRPr sz="2400" b="1">
-                <a:solidFill>
-                  <a:srgbClr val="FFFFFF"/>
-                </a:solidFill>
-                <a:latin typeface="Arial"/>
-              </a:defRPr>
-            </a:pPr>
-            <a:r>
-              <a:t>Estudio Económico: Presupuesto Mínimo Solicitado (Fase 1)</a:t>
+              <a:defRPr sz="2200" b="1">
+                <a:solidFill>
+                  <a:srgbClr val="0F172A"/>
+                </a:solidFill>
+                <a:latin typeface="Arial"/>
+              </a:defRPr>
+            </a:pPr>
+            <a:r>
+              <a:t>Estudio Económico y Presupuesto de Inversión: Fase 1</a:t>
             </a:r>
           </a:p>
         </p:txBody>
@@ -8219,7 +8219,7 @@
         <p:spPr>
           <a:xfrm>
             <a:off x="10789920" y="365760"/>
-            <a:ext cx="731520" cy="731520"/>
+            <a:ext cx="685800" cy="685800"/>
           </a:xfrm>
           <a:prstGeom prst="rect">
             <a:avLst/>
@@ -8234,14 +8234,14 @@
         </p:nvSpPr>
         <p:spPr>
           <a:xfrm>
-            <a:off x="731520" y="1463040"/>
+            <a:off x="731520" y="1371600"/>
             <a:ext cx="10728655" cy="18288"/>
           </a:xfrm>
           <a:prstGeom prst="rect">
             <a:avLst/>
           </a:prstGeom>
           <a:solidFill>
-            <a:srgbClr val="334155"/>
+            <a:srgbClr val="1E3A8A"/>
           </a:solidFill>
           <a:ln>
             <a:noFill/>
@@ -8277,17 +8277,19 @@
         </p:nvSpPr>
         <p:spPr>
           <a:xfrm>
-            <a:off x="731520" y="1645920"/>
-            <a:ext cx="10728655" cy="822960"/>
+            <a:off x="731520" y="1600200"/>
+            <a:ext cx="10728655" cy="777240"/>
           </a:xfrm>
           <a:prstGeom prst="roundRect">
             <a:avLst/>
           </a:prstGeom>
           <a:solidFill>
-            <a:srgbClr val="0284C7"/>
+            <a:srgbClr val="E0F2FE"/>
           </a:solidFill>
           <a:ln>
-            <a:noFill/>
+            <a:solidFill>
+              <a:srgbClr val="0284C7"/>
+            </a:solidFill>
           </a:ln>
         </p:spPr>
         <p:style>
@@ -8320,8 +8322,8 @@
         </p:nvSpPr>
         <p:spPr>
           <a:xfrm>
-            <a:off x="914400" y="1691640"/>
-            <a:ext cx="10362895" cy="731520"/>
+            <a:off x="914400" y="1645920"/>
+            <a:ext cx="10362895" cy="685800"/>
           </a:xfrm>
           <a:prstGeom prst="rect">
             <a:avLst/>
@@ -8335,28 +8337,28 @@
           <a:lstStyle/>
           <a:p>
             <a:pPr algn="ctr">
-              <a:defRPr sz="1900" b="1">
-                <a:solidFill>
-                  <a:srgbClr val="FFFFFF"/>
-                </a:solidFill>
-                <a:latin typeface="Arial"/>
-              </a:defRPr>
-            </a:pPr>
-            <a:r>
-              <a:t>Inversión Mínima: ~$24.50 USD / mes   |   $294.00 USD / AÑO TOTAL</a:t>
+              <a:defRPr sz="1800" b="1">
+                <a:solidFill>
+                  <a:srgbClr val="1E3A8A"/>
+                </a:solidFill>
+                <a:latin typeface="Arial"/>
+              </a:defRPr>
+            </a:pPr>
+            <a:r>
+              <a:t>Presupuesto Solicitado: ~$24.50 USD / mes   |   $294.00 USD / AÑO TOTAL</a:t>
             </a:r>
           </a:p>
           <a:p>
             <a:pPr algn="ctr">
-              <a:defRPr sz="1150">
-                <a:solidFill>
-                  <a:srgbClr val="E2E8F0"/>
-                </a:solidFill>
-                <a:latin typeface="Arial"/>
-              </a:defRPr>
-            </a:pPr>
-            <a:r>
-              <a:t>El desarrollo de software y arquitectura fue provisto sin costo de honorarios por el Equipo Técnico</a:t>
+              <a:defRPr sz="1100">
+                <a:solidFill>
+                  <a:srgbClr val="334155"/>
+                </a:solidFill>
+                <a:latin typeface="Arial"/>
+              </a:defRPr>
+            </a:pPr>
+            <a:r>
+              <a:t>Inversión exclusiva en infraestructura de nube • Honorarios de desarrollo provistos como aporte técnico ($0.00)</a:t>
             </a:r>
           </a:p>
         </p:txBody>
@@ -8370,8 +8372,8 @@
           <p:nvPr/>
         </p:nvGraphicFramePr>
         <p:xfrm>
-          <a:off x="731520" y="2651760"/>
-          <a:ext cx="10728655" cy="3291840"/>
+          <a:off x="731520" y="2560320"/>
+          <a:ext cx="10728655" cy="3474720"/>
         </p:xfrm>
         <a:graphic>
           <a:graphicData uri="http://schemas.openxmlformats.org/drawingml/2006/table">
@@ -8385,27 +8387,27 @@
                 <a:gridCol w="1554480"/>
                 <a:gridCol w="1554480"/>
               </a:tblGrid>
-              <a:tr h="548640">
+              <a:tr h="579120">
                 <a:tc>
                   <a:txBody>
                     <a:bodyPr/>
                     <a:lstStyle/>
                     <a:p>
                       <a:pPr>
-                        <a:defRPr b="1" sz="1200">
+                        <a:defRPr b="1" sz="1150">
                           <a:solidFill>
-                            <a:srgbClr val="38BDF8"/>
+                            <a:srgbClr val="FFFFFF"/>
                           </a:solidFill>
                         </a:defRPr>
                       </a:pPr>
                       <a:r>
-                        <a:t>Componente</a:t>
+                        <a:t>Componente de Infraestructura</a:t>
                       </a:r>
                     </a:p>
                   </a:txBody>
                   <a:tcPr>
                     <a:solidFill>
-                      <a:srgbClr val="0F172A"/>
+                      <a:srgbClr val="1E3A8A"/>
                     </a:solidFill>
                   </a:tcPr>
                 </a:tc>
@@ -8415,20 +8417,20 @@
                     <a:lstStyle/>
                     <a:p>
                       <a:pPr>
-                        <a:defRPr b="1" sz="1200">
+                        <a:defRPr b="1" sz="1150">
                           <a:solidFill>
-                            <a:srgbClr val="38BDF8"/>
+                            <a:srgbClr val="FFFFFF"/>
                           </a:solidFill>
                         </a:defRPr>
                       </a:pPr>
                       <a:r>
-                        <a:t>Especificación Técnica</a:t>
+                        <a:t>Especificación Técnica Mínima</a:t>
                       </a:r>
                     </a:p>
                   </a:txBody>
                   <a:tcPr>
                     <a:solidFill>
-                      <a:srgbClr val="0F172A"/>
+                      <a:srgbClr val="1E3A8A"/>
                     </a:solidFill>
                   </a:tcPr>
                 </a:tc>
@@ -8438,20 +8440,20 @@
                     <a:lstStyle/>
                     <a:p>
                       <a:pPr algn="ctr">
-                        <a:defRPr b="1" sz="1200">
+                        <a:defRPr b="1" sz="1150">
                           <a:solidFill>
-                            <a:srgbClr val="38BDF8"/>
+                            <a:srgbClr val="FFFFFF"/>
                           </a:solidFill>
                         </a:defRPr>
                       </a:pPr>
                       <a:r>
-                        <a:t>Mensual</a:t>
+                        <a:t>Costo Mensual</a:t>
                       </a:r>
                     </a:p>
                   </a:txBody>
                   <a:tcPr>
                     <a:solidFill>
-                      <a:srgbClr val="0F172A"/>
+                      <a:srgbClr val="1E3A8A"/>
                     </a:solidFill>
                   </a:tcPr>
                 </a:tc>
@@ -8461,25 +8463,25 @@
                     <a:lstStyle/>
                     <a:p>
                       <a:pPr algn="ctr">
-                        <a:defRPr b="1" sz="1200">
+                        <a:defRPr b="1" sz="1150">
                           <a:solidFill>
-                            <a:srgbClr val="38BDF8"/>
+                            <a:srgbClr val="FFFFFF"/>
                           </a:solidFill>
                         </a:defRPr>
                       </a:pPr>
                       <a:r>
-                        <a:t>Anual Total</a:t>
+                        <a:t>Costo Anual</a:t>
                       </a:r>
                     </a:p>
                   </a:txBody>
                   <a:tcPr>
                     <a:solidFill>
-                      <a:srgbClr val="0F172A"/>
+                      <a:srgbClr val="1E3A8A"/>
                     </a:solidFill>
                   </a:tcPr>
                 </a:tc>
               </a:tr>
-              <a:tr h="548640">
+              <a:tr h="579120">
                 <a:tc>
                   <a:txBody>
                     <a:bodyPr/>
@@ -8488,7 +8490,7 @@
                       <a:pPr>
                         <a:defRPr sz="1100" b="1">
                           <a:solidFill>
-                            <a:srgbClr val="38BDF8"/>
+                            <a:srgbClr val="0F172A"/>
                           </a:solidFill>
                           <a:latin typeface="Arial"/>
                         </a:defRPr>
@@ -8500,7 +8502,7 @@
                   </a:txBody>
                   <a:tcPr>
                     <a:solidFill>
-                      <a:srgbClr val="1E293B"/>
+                      <a:srgbClr val="FFFFFF"/>
                     </a:solidFill>
                   </a:tcPr>
                 </a:tc>
@@ -8512,19 +8514,19 @@
                       <a:pPr>
                         <a:defRPr sz="1100" b="0">
                           <a:solidFill>
-                            <a:srgbClr val="E2E8F0"/>
+                            <a:srgbClr val="0F172A"/>
                           </a:solidFill>
                           <a:latin typeface="Arial"/>
                         </a:defRPr>
                       </a:pPr>
                       <a:r>
-                        <a:t>4 vCPU / 8 GB RAM / 100 GB SSD NVMe / Red 1 Gbps / Anti-DDoS</a:t>
+                        <a:t>4 vCPU / 8 GB RAM / 100 GB SSD NVMe / Red 1 Gbps / Protección contra ataques</a:t>
                       </a:r>
                     </a:p>
                   </a:txBody>
                   <a:tcPr>
                     <a:solidFill>
-                      <a:srgbClr val="1E293B"/>
+                      <a:srgbClr val="FFFFFF"/>
                     </a:solidFill>
                   </a:tcPr>
                 </a:tc>
@@ -8536,7 +8538,7 @@
                       <a:pPr algn="ctr">
                         <a:defRPr sz="1100" b="0">
                           <a:solidFill>
-                            <a:srgbClr val="E2E8F0"/>
+                            <a:srgbClr val="0F172A"/>
                           </a:solidFill>
                           <a:latin typeface="Arial"/>
                         </a:defRPr>
@@ -8548,7 +8550,7 @@
                   </a:txBody>
                   <a:tcPr>
                     <a:solidFill>
-                      <a:srgbClr val="1E293B"/>
+                      <a:srgbClr val="FFFFFF"/>
                     </a:solidFill>
                   </a:tcPr>
                 </a:tc>
@@ -8560,7 +8562,7 @@
                       <a:pPr algn="ctr">
                         <a:defRPr sz="1100" b="0">
                           <a:solidFill>
-                            <a:srgbClr val="E2E8F0"/>
+                            <a:srgbClr val="0F172A"/>
                           </a:solidFill>
                           <a:latin typeface="Arial"/>
                         </a:defRPr>
@@ -8572,12 +8574,12 @@
                   </a:txBody>
                   <a:tcPr>
                     <a:solidFill>
-                      <a:srgbClr val="1E293B"/>
+                      <a:srgbClr val="FFFFFF"/>
                     </a:solidFill>
                   </a:tcPr>
                 </a:tc>
               </a:tr>
-              <a:tr h="548640">
+              <a:tr h="579120">
                 <a:tc>
                   <a:txBody>
                     <a:bodyPr/>
@@ -8586,7 +8588,7 @@
                       <a:pPr>
                         <a:defRPr sz="1100" b="1">
                           <a:solidFill>
-                            <a:srgbClr val="38BDF8"/>
+                            <a:srgbClr val="0F172A"/>
                           </a:solidFill>
                           <a:latin typeface="Arial"/>
                         </a:defRPr>
@@ -8598,7 +8600,7 @@
                   </a:txBody>
                   <a:tcPr>
                     <a:solidFill>
-                      <a:srgbClr val="1E293B"/>
+                      <a:srgbClr val="F1F5F9"/>
                     </a:solidFill>
                   </a:tcPr>
                 </a:tc>
@@ -8610,19 +8612,19 @@
                       <a:pPr>
                         <a:defRPr sz="1100" b="0">
                           <a:solidFill>
-                            <a:srgbClr val="E2E8F0"/>
+                            <a:srgbClr val="0F172A"/>
                           </a:solidFill>
                           <a:latin typeface="Arial"/>
                         </a:defRPr>
                       </a:pPr>
                       <a:r>
-                        <a:t>Registro anual de dominio web + Certificado SSL 256 bits</a:t>
+                        <a:t>Registro anual de dominio web corporativo + Certificado SSL Wildcard (256 bits)</a:t>
                       </a:r>
                     </a:p>
                   </a:txBody>
                   <a:tcPr>
                     <a:solidFill>
-                      <a:srgbClr val="1E293B"/>
+                      <a:srgbClr val="F1F5F9"/>
                     </a:solidFill>
                   </a:tcPr>
                 </a:tc>
@@ -8634,7 +8636,7 @@
                       <a:pPr algn="ctr">
                         <a:defRPr sz="1100" b="0">
                           <a:solidFill>
-                            <a:srgbClr val="E2E8F0"/>
+                            <a:srgbClr val="0F172A"/>
                           </a:solidFill>
                           <a:latin typeface="Arial"/>
                         </a:defRPr>
@@ -8646,7 +8648,7 @@
                   </a:txBody>
                   <a:tcPr>
                     <a:solidFill>
-                      <a:srgbClr val="1E293B"/>
+                      <a:srgbClr val="F1F5F9"/>
                     </a:solidFill>
                   </a:tcPr>
                 </a:tc>
@@ -8658,7 +8660,7 @@
                       <a:pPr algn="ctr">
                         <a:defRPr sz="1100" b="0">
                           <a:solidFill>
-                            <a:srgbClr val="E2E8F0"/>
+                            <a:srgbClr val="0F172A"/>
                           </a:solidFill>
                           <a:latin typeface="Arial"/>
                         </a:defRPr>
@@ -8670,12 +8672,12 @@
                   </a:txBody>
                   <a:tcPr>
                     <a:solidFill>
-                      <a:srgbClr val="1E293B"/>
+                      <a:srgbClr val="F1F5F9"/>
                     </a:solidFill>
                   </a:tcPr>
                 </a:tc>
               </a:tr>
-              <a:tr h="548640">
+              <a:tr h="579120">
                 <a:tc>
                   <a:txBody>
                     <a:bodyPr/>
@@ -8684,7 +8686,7 @@
                       <a:pPr>
                         <a:defRPr sz="1100" b="1">
                           <a:solidFill>
-                            <a:srgbClr val="38BDF8"/>
+                            <a:srgbClr val="0F172A"/>
                           </a:solidFill>
                           <a:latin typeface="Arial"/>
                         </a:defRPr>
@@ -8696,7 +8698,7 @@
                   </a:txBody>
                   <a:tcPr>
                     <a:solidFill>
-                      <a:srgbClr val="1E293B"/>
+                      <a:srgbClr val="FFFFFF"/>
                     </a:solidFill>
                   </a:tcPr>
                 </a:tc>
@@ -8708,19 +8710,19 @@
                       <a:pPr>
                         <a:defRPr sz="1100" b="0">
                           <a:solidFill>
-                            <a:srgbClr val="E2E8F0"/>
+                            <a:srgbClr val="0F172A"/>
                           </a:solidFill>
                           <a:latin typeface="Arial"/>
                         </a:defRPr>
                       </a:pPr>
                       <a:r>
-                        <a:t>Dirección IP estática exclusiva para filtrado seguro de conexiones</a:t>
+                        <a:t>Dirección IP estática exclusiva para filtrado de seguridad en consola de mando</a:t>
                       </a:r>
                     </a:p>
                   </a:txBody>
                   <a:tcPr>
                     <a:solidFill>
-                      <a:srgbClr val="1E293B"/>
+                      <a:srgbClr val="FFFFFF"/>
                     </a:solidFill>
                   </a:tcPr>
                 </a:tc>
@@ -8732,7 +8734,7 @@
                       <a:pPr algn="ctr">
                         <a:defRPr sz="1100" b="0">
                           <a:solidFill>
-                            <a:srgbClr val="E2E8F0"/>
+                            <a:srgbClr val="0F172A"/>
                           </a:solidFill>
                           <a:latin typeface="Arial"/>
                         </a:defRPr>
@@ -8744,7 +8746,7 @@
                   </a:txBody>
                   <a:tcPr>
                     <a:solidFill>
-                      <a:srgbClr val="1E293B"/>
+                      <a:srgbClr val="FFFFFF"/>
                     </a:solidFill>
                   </a:tcPr>
                 </a:tc>
@@ -8756,7 +8758,7 @@
                       <a:pPr algn="ctr">
                         <a:defRPr sz="1100" b="0">
                           <a:solidFill>
-                            <a:srgbClr val="E2E8F0"/>
+                            <a:srgbClr val="0F172A"/>
                           </a:solidFill>
                           <a:latin typeface="Arial"/>
                         </a:defRPr>
@@ -8768,12 +8770,12 @@
                   </a:txBody>
                   <a:tcPr>
                     <a:solidFill>
-                      <a:srgbClr val="1E293B"/>
+                      <a:srgbClr val="FFFFFF"/>
                     </a:solidFill>
                   </a:tcPr>
                 </a:tc>
               </a:tr>
-              <a:tr h="548640">
+              <a:tr h="579120">
                 <a:tc>
                   <a:txBody>
                     <a:bodyPr/>
@@ -8782,7 +8784,7 @@
                       <a:pPr>
                         <a:defRPr sz="1100" b="1">
                           <a:solidFill>
-                            <a:srgbClr val="38BDF8"/>
+                            <a:srgbClr val="0F172A"/>
                           </a:solidFill>
                           <a:latin typeface="Arial"/>
                         </a:defRPr>
@@ -8794,7 +8796,7 @@
                   </a:txBody>
                   <a:tcPr>
                     <a:solidFill>
-                      <a:srgbClr val="1E293B"/>
+                      <a:srgbClr val="F1F5F9"/>
                     </a:solidFill>
                   </a:tcPr>
                 </a:tc>
@@ -8806,19 +8808,19 @@
                       <a:pPr>
                         <a:defRPr sz="1100" b="0">
                           <a:solidFill>
-                            <a:srgbClr val="E2E8F0"/>
+                            <a:srgbClr val="0F172A"/>
                           </a:solidFill>
                           <a:latin typeface="Arial"/>
                         </a:defRPr>
                       </a:pPr>
                       <a:r>
-                        <a:t>Linux Ubuntu Server, Nginx, PostgreSQL, Fail2ban (FOSS)</a:t>
+                        <a:t>Entorno Linux Ubuntu Server, Nginx, PostgreSQL, Fail2ban y módulos FOSS</a:t>
                       </a:r>
                     </a:p>
                   </a:txBody>
                   <a:tcPr>
                     <a:solidFill>
-                      <a:srgbClr val="1E293B"/>
+                      <a:srgbClr val="F1F5F9"/>
                     </a:solidFill>
                   </a:tcPr>
                 </a:tc>
@@ -8830,7 +8832,7 @@
                       <a:pPr algn="ctr">
                         <a:defRPr sz="1100" b="0">
                           <a:solidFill>
-                            <a:srgbClr val="E2E8F0"/>
+                            <a:srgbClr val="0F172A"/>
                           </a:solidFill>
                           <a:latin typeface="Arial"/>
                         </a:defRPr>
@@ -8842,7 +8844,7 @@
                   </a:txBody>
                   <a:tcPr>
                     <a:solidFill>
-                      <a:srgbClr val="1E293B"/>
+                      <a:srgbClr val="F1F5F9"/>
                     </a:solidFill>
                   </a:tcPr>
                 </a:tc>
@@ -8854,7 +8856,7 @@
                       <a:pPr algn="ctr">
                         <a:defRPr sz="1100" b="0">
                           <a:solidFill>
-                            <a:srgbClr val="E2E8F0"/>
+                            <a:srgbClr val="0F172A"/>
                           </a:solidFill>
                           <a:latin typeface="Arial"/>
                         </a:defRPr>
@@ -8866,33 +8868,33 @@
                   </a:txBody>
                   <a:tcPr>
                     <a:solidFill>
-                      <a:srgbClr val="1E293B"/>
+                      <a:srgbClr val="F1F5F9"/>
                     </a:solidFill>
                   </a:tcPr>
                 </a:tc>
               </a:tr>
-              <a:tr h="548640">
+              <a:tr h="579120">
                 <a:tc>
                   <a:txBody>
                     <a:bodyPr/>
                     <a:lstStyle/>
                     <a:p>
                       <a:pPr>
-                        <a:defRPr sz="1200" b="1">
+                        <a:defRPr sz="1150" b="1">
                           <a:solidFill>
-                            <a:srgbClr val="FFFFFF"/>
+                            <a:srgbClr val="1E3A8A"/>
                           </a:solidFill>
                           <a:latin typeface="Arial"/>
                         </a:defRPr>
                       </a:pPr>
                       <a:r>
-                        <a:t>TOTAL MÍNIMO SOLICITADO:</a:t>
+                        <a:t>TOTAL MÍNIMO SOLICITADO (FASE 1):</a:t>
                       </a:r>
                     </a:p>
                   </a:txBody>
                   <a:tcPr>
                     <a:solidFill>
-                      <a:srgbClr val="022C4B"/>
+                      <a:srgbClr val="E0F2FE"/>
                     </a:solidFill>
                   </a:tcPr>
                 </a:tc>
@@ -8902,21 +8904,21 @@
                     <a:lstStyle/>
                     <a:p>
                       <a:pPr>
-                        <a:defRPr sz="1200" b="1">
+                        <a:defRPr sz="1150" b="1">
                           <a:solidFill>
-                            <a:srgbClr val="FFFFFF"/>
+                            <a:srgbClr val="1E3A8A"/>
                           </a:solidFill>
                           <a:latin typeface="Arial"/>
                         </a:defRPr>
                       </a:pPr>
                       <a:r>
-                        <a:t>Infraestructura soberana y certificada para las pruebas piloto</a:t>
+                        <a:t>Infraestructura cloud dedicada y certificada para las pruebas piloto</a:t>
                       </a:r>
                     </a:p>
                   </a:txBody>
                   <a:tcPr>
                     <a:solidFill>
-                      <a:srgbClr val="022C4B"/>
+                      <a:srgbClr val="E0F2FE"/>
                     </a:solidFill>
                   </a:tcPr>
                 </a:tc>
@@ -8926,9 +8928,9 @@
                     <a:lstStyle/>
                     <a:p>
                       <a:pPr algn="ctr">
-                        <a:defRPr sz="1200" b="1">
+                        <a:defRPr sz="1150" b="1">
                           <a:solidFill>
-                            <a:srgbClr val="4ADE80"/>
+                            <a:srgbClr val="1E3A8A"/>
                           </a:solidFill>
                           <a:latin typeface="Arial"/>
                         </a:defRPr>
@@ -8940,7 +8942,7 @@
                   </a:txBody>
                   <a:tcPr>
                     <a:solidFill>
-                      <a:srgbClr val="022C4B"/>
+                      <a:srgbClr val="E0F2FE"/>
                     </a:solidFill>
                   </a:tcPr>
                 </a:tc>
@@ -8950,9 +8952,9 @@
                     <a:lstStyle/>
                     <a:p>
                       <a:pPr algn="ctr">
-                        <a:defRPr sz="1200" b="1">
+                        <a:defRPr sz="1150" b="1">
                           <a:solidFill>
-                            <a:srgbClr val="4ADE80"/>
+                            <a:srgbClr val="1E3A8A"/>
                           </a:solidFill>
                           <a:latin typeface="Arial"/>
                         </a:defRPr>
@@ -8964,7 +8966,7 @@
                   </a:txBody>
                   <a:tcPr>
                     <a:solidFill>
-                      <a:srgbClr val="022C4B"/>
+                      <a:srgbClr val="E0F2FE"/>
                     </a:solidFill>
                   </a:tcPr>
                 </a:tc>
@@ -9006,7 +9008,7 @@
             <a:avLst/>
           </a:prstGeom>
           <a:solidFill>
-            <a:srgbClr val="0F172A"/>
+            <a:srgbClr val="F8FAFC"/>
           </a:solidFill>
           <a:ln>
             <a:noFill/>
@@ -9043,7 +9045,7 @@
         <p:spPr>
           <a:xfrm>
             <a:off x="731520" y="365760"/>
-            <a:ext cx="9144000" cy="365760"/>
+            <a:ext cx="9144000" cy="320040"/>
           </a:xfrm>
           <a:prstGeom prst="rect">
             <a:avLst/>
@@ -9057,15 +9059,15 @@
           <a:lstStyle/>
           <a:p>
             <a:pPr>
-              <a:defRPr sz="1100" b="1">
-                <a:solidFill>
-                  <a:srgbClr val="38BDF8"/>
-                </a:solidFill>
-                <a:latin typeface="Arial"/>
-              </a:defRPr>
-            </a:pPr>
-            <a:r>
-              <a:t>MIGATO • EQUIPO TÉCNICO DE SISTEMAS</a:t>
+              <a:defRPr sz="1000" b="1">
+                <a:solidFill>
+                  <a:srgbClr val="0284C7"/>
+                </a:solidFill>
+                <a:latin typeface="Arial"/>
+              </a:defRPr>
+            </a:pPr>
+            <a:r>
+              <a:t>MIGATO • EQUIPO TÉCNICO DE SISTEMAS Y ARQUITECTURA DIGITAL</a:t>
             </a:r>
           </a:p>
         </p:txBody>
@@ -9078,8 +9080,8 @@
         </p:nvSpPr>
         <p:spPr>
           <a:xfrm>
-            <a:off x="731520" y="685800"/>
-            <a:ext cx="9601200" cy="731520"/>
+            <a:off x="731520" y="658368"/>
+            <a:ext cx="9601200" cy="685800"/>
           </a:xfrm>
           <a:prstGeom prst="rect">
             <a:avLst/>
@@ -9093,9 +9095,9 @@
           <a:lstStyle/>
           <a:p>
             <a:pPr>
-              <a:defRPr sz="2400" b="1">
-                <a:solidFill>
-                  <a:srgbClr val="FFFFFF"/>
+              <a:defRPr sz="2200" b="1">
+                <a:solidFill>
+                  <a:srgbClr val="0F172A"/>
                 </a:solidFill>
                 <a:latin typeface="Arial"/>
               </a:defRPr>
@@ -9123,7 +9125,7 @@
         <p:spPr>
           <a:xfrm>
             <a:off x="10789920" y="365760"/>
-            <a:ext cx="731520" cy="731520"/>
+            <a:ext cx="685800" cy="685800"/>
           </a:xfrm>
           <a:prstGeom prst="rect">
             <a:avLst/>
@@ -9138,14 +9140,14 @@
         </p:nvSpPr>
         <p:spPr>
           <a:xfrm>
-            <a:off x="731520" y="1463040"/>
+            <a:off x="731520" y="1371600"/>
             <a:ext cx="10728655" cy="18288"/>
           </a:xfrm>
           <a:prstGeom prst="rect">
             <a:avLst/>
           </a:prstGeom>
           <a:solidFill>
-            <a:srgbClr val="334155"/>
+            <a:srgbClr val="1E3A8A"/>
           </a:solidFill>
           <a:ln>
             <a:noFill/>
@@ -9181,18 +9183,18 @@
         </p:nvSpPr>
         <p:spPr>
           <a:xfrm>
-            <a:off x="731520" y="1737360"/>
-            <a:ext cx="5120640" cy="4389120"/>
+            <a:off x="731520" y="1645920"/>
+            <a:ext cx="5120640" cy="4572000"/>
           </a:xfrm>
           <a:prstGeom prst="roundRect">
             <a:avLst/>
           </a:prstGeom>
           <a:solidFill>
-            <a:srgbClr val="1E293B"/>
+            <a:srgbClr val="FFFFFF"/>
           </a:solidFill>
           <a:ln>
             <a:solidFill>
-              <a:srgbClr val="4ADE80"/>
+              <a:srgbClr val="059669"/>
             </a:solidFill>
           </a:ln>
         </p:spPr>
@@ -9226,8 +9228,8 @@
         </p:nvSpPr>
         <p:spPr>
           <a:xfrm>
-            <a:off x="1005840" y="1920240"/>
-            <a:ext cx="4572000" cy="4023360"/>
+            <a:off x="1005840" y="1828800"/>
+            <a:ext cx="4572000" cy="4114800"/>
           </a:xfrm>
           <a:prstGeom prst="rect">
             <a:avLst/>
@@ -9242,17 +9244,17 @@
           <a:p>
             <a:pPr>
               <a:spcAft>
-                <a:spcPts val="1000"/>
+                <a:spcPts val="600"/>
               </a:spcAft>
-              <a:defRPr sz="1600" b="1">
-                <a:solidFill>
-                  <a:srgbClr val="4ADE80"/>
-                </a:solidFill>
-                <a:latin typeface="Arial"/>
-              </a:defRPr>
-            </a:pPr>
-            <a:r>
-              <a:t>🚀 FASE 1: Inmediata ($294.00 USD)</a:t>
+              <a:defRPr sz="1500" b="1">
+                <a:solidFill>
+                  <a:srgbClr val="059669"/>
+                </a:solidFill>
+                <a:latin typeface="Arial"/>
+              </a:defRPr>
+            </a:pPr>
+            <a:r>
+              <a:t>🚀 FASE 1: Inmediata (Objeto de esta Solicitud)</a:t>
             </a:r>
           </a:p>
           <a:p>
@@ -9260,15 +9262,15 @@
               <a:spcAft>
                 <a:spcPts val="1200"/>
               </a:spcAft>
-              <a:defRPr sz="1200" i="1">
-                <a:solidFill>
-                  <a:srgbClr val="94A3B8"/>
-                </a:solidFill>
-                <a:latin typeface="Arial"/>
-              </a:defRPr>
-            </a:pPr>
-            <a:r>
-              <a:t>Objeto directo de esta solicitud de financiamiento:</a:t>
+              <a:defRPr sz="1150" i="1">
+                <a:solidFill>
+                  <a:srgbClr val="64748B"/>
+                </a:solidFill>
+                <a:latin typeface="Arial"/>
+              </a:defRPr>
+            </a:pPr>
+            <a:r>
+              <a:t>Inversión requerida: $294.00 USD anuales</a:t>
             </a:r>
           </a:p>
           <a:p>
@@ -9276,15 +9278,15 @@
               <a:spcAft>
                 <a:spcPts val="800"/>
               </a:spcAft>
-              <a:defRPr sz="1200">
-                <a:solidFill>
-                  <a:srgbClr val="E2E8F0"/>
-                </a:solidFill>
-                <a:latin typeface="Arial"/>
-              </a:defRPr>
-            </a:pPr>
-            <a:r>
-              <a:t>• Contratación del VPS dedicado y registro del dominio oficial.</a:t>
+              <a:defRPr sz="1150">
+                <a:solidFill>
+                  <a:srgbClr val="334155"/>
+                </a:solidFill>
+                <a:latin typeface="Arial"/>
+              </a:defRPr>
+            </a:pPr>
+            <a:r>
+              <a:t>▪ Contratación del servidor cloud VPS y vinculación del dominio institucional.</a:t>
             </a:r>
           </a:p>
           <a:p>
@@ -9292,15 +9294,15 @@
               <a:spcAft>
                 <a:spcPts val="800"/>
               </a:spcAft>
-              <a:defRPr sz="1200">
-                <a:solidFill>
-                  <a:srgbClr val="E2E8F0"/>
-                </a:solidFill>
-                <a:latin typeface="Arial"/>
-              </a:defRPr>
-            </a:pPr>
-            <a:r>
-              <a:t>• Instalación del entorno Linux blindado con cortafuegos y certificados SSL 256 bits.</a:t>
+              <a:defRPr sz="1150">
+                <a:solidFill>
+                  <a:srgbClr val="334155"/>
+                </a:solidFill>
+                <a:latin typeface="Arial"/>
+              </a:defRPr>
+            </a:pPr>
+            <a:r>
+              <a:t>▪ Instalación de la arquitectura de seguridad, reglas de firewall y certificados SSL de 256 bits.</a:t>
             </a:r>
           </a:p>
           <a:p>
@@ -9308,15 +9310,15 @@
               <a:spcAft>
                 <a:spcPts val="800"/>
               </a:spcAft>
-              <a:defRPr sz="1200">
-                <a:solidFill>
-                  <a:srgbClr val="E2E8F0"/>
-                </a:solidFill>
-                <a:latin typeface="Arial"/>
-              </a:defRPr>
-            </a:pPr>
-            <a:r>
-              <a:t>• Ejecución de pruebas de carga y concurrencia con simulación de tráfico real.</a:t>
+              <a:defRPr sz="1150">
+                <a:solidFill>
+                  <a:srgbClr val="334155"/>
+                </a:solidFill>
+                <a:latin typeface="Arial"/>
+              </a:defRPr>
+            </a:pPr>
+            <a:r>
+              <a:t>▪ Ejecución de pruebas de carga, concurrencia y auditoría técnica de puertos.</a:t>
             </a:r>
           </a:p>
           <a:p>
@@ -9324,15 +9326,15 @@
               <a:spcAft>
                 <a:spcPts val="800"/>
               </a:spcAft>
-              <a:defRPr sz="1200">
-                <a:solidFill>
-                  <a:srgbClr val="E2E8F0"/>
-                </a:solidFill>
-                <a:latin typeface="Arial"/>
-              </a:defRPr>
-            </a:pPr>
-            <a:r>
-              <a:t>• Despliegue y validación en 3 parroquias piloto de Maturín: Las Cocuizas, San Simón y Alto de Los Godos.</a:t>
+              <a:defRPr sz="1150">
+                <a:solidFill>
+                  <a:srgbClr val="334155"/>
+                </a:solidFill>
+                <a:latin typeface="Arial"/>
+              </a:defRPr>
+            </a:pPr>
+            <a:r>
+              <a:t>▪ Validación operativa en 3 parroquias piloto de Maturín: Las Cocuizas, San Simón y Alto de Los Godos con coordinadores reales.</a:t>
             </a:r>
           </a:p>
         </p:txBody>
@@ -9345,18 +9347,18 @@
         </p:nvSpPr>
         <p:spPr>
           <a:xfrm>
-            <a:off x="6217920" y="1737360"/>
-            <a:ext cx="5212080" cy="4389120"/>
+            <a:off x="6217920" y="1645920"/>
+            <a:ext cx="5212080" cy="4572000"/>
           </a:xfrm>
           <a:prstGeom prst="roundRect">
             <a:avLst/>
           </a:prstGeom>
           <a:solidFill>
-            <a:srgbClr val="1E293B"/>
+            <a:srgbClr val="FFFFFF"/>
           </a:solidFill>
           <a:ln>
             <a:solidFill>
-              <a:srgbClr val="334155"/>
+              <a:srgbClr val="CBD5E1"/>
             </a:solidFill>
           </a:ln>
         </p:spPr>
@@ -9390,8 +9392,8 @@
         </p:nvSpPr>
         <p:spPr>
           <a:xfrm>
-            <a:off x="6492240" y="1920240"/>
-            <a:ext cx="4663440" cy="4023360"/>
+            <a:off x="6492240" y="1828800"/>
+            <a:ext cx="4663440" cy="4114800"/>
           </a:xfrm>
           <a:prstGeom prst="rect">
             <a:avLst/>
@@ -9406,17 +9408,17 @@
           <a:p>
             <a:pPr>
               <a:spcAft>
-                <a:spcPts val="1000"/>
+                <a:spcPts val="600"/>
               </a:spcAft>
-              <a:defRPr sz="1600" b="1">
-                <a:solidFill>
-                  <a:srgbClr val="94A3B8"/>
-                </a:solidFill>
-                <a:latin typeface="Arial"/>
-              </a:defRPr>
-            </a:pPr>
-            <a:r>
-              <a:t>🏢 FASE 2: Consolidación Futura</a:t>
+              <a:defRPr sz="1500" b="1">
+                <a:solidFill>
+                  <a:srgbClr val="0F172A"/>
+                </a:solidFill>
+                <a:latin typeface="Arial"/>
+              </a:defRPr>
+            </a:pPr>
+            <a:r>
+              <a:t>🏢 FASE 2: Consolidación de Sala Situacional Física</a:t>
             </a:r>
           </a:p>
           <a:p>
@@ -9424,15 +9426,15 @@
               <a:spcAft>
                 <a:spcPts val="1200"/>
               </a:spcAft>
-              <a:defRPr sz="1200" i="1">
-                <a:solidFill>
-                  <a:srgbClr val="94A3B8"/>
-                </a:solidFill>
-                <a:latin typeface="Arial"/>
-              </a:defRPr>
-            </a:pPr>
-            <a:r>
-              <a:t>Sujeta a etapas posteriores y disponibilidad de recursos:</a:t>
+              <a:defRPr sz="1150" i="1">
+                <a:solidFill>
+                  <a:srgbClr val="64748B"/>
+                </a:solidFill>
+                <a:latin typeface="Arial"/>
+              </a:defRPr>
+            </a:pPr>
+            <a:r>
+              <a:t>Planificación diferida sujeta a disponibilidad de recursos:</a:t>
             </a:r>
           </a:p>
           <a:p>
@@ -9440,15 +9442,15 @@
               <a:spcAft>
                 <a:spcPts val="800"/>
               </a:spcAft>
-              <a:defRPr sz="1200">
-                <a:solidFill>
-                  <a:srgbClr val="94A3B8"/>
-                </a:solidFill>
-                <a:latin typeface="Arial"/>
-              </a:defRPr>
-            </a:pPr>
-            <a:r>
-              <a:t>• Dotación física del centro de mando y monitoreo regional.</a:t>
+              <a:defRPr sz="1150">
+                <a:solidFill>
+                  <a:srgbClr val="64748B"/>
+                </a:solidFill>
+                <a:latin typeface="Arial"/>
+              </a:defRPr>
+            </a:pPr>
+            <a:r>
+              <a:t>▪ Acondicionamiento físico del centro de seguimiento y monitoreo territorial.</a:t>
             </a:r>
           </a:p>
           <a:p>
@@ -9456,15 +9458,15 @@
               <a:spcAft>
                 <a:spcPts val="800"/>
               </a:spcAft>
-              <a:defRPr sz="1200">
-                <a:solidFill>
-                  <a:srgbClr val="94A3B8"/>
-                </a:solidFill>
-                <a:latin typeface="Arial"/>
-              </a:defRPr>
-            </a:pPr>
-            <a:r>
-              <a:t>• Equipos de computación dedicados para operadores de sala situacional.</a:t>
+              <a:defRPr sz="1150">
+                <a:solidFill>
+                  <a:srgbClr val="64748B"/>
+                </a:solidFill>
+                <a:latin typeface="Arial"/>
+              </a:defRPr>
+            </a:pPr>
+            <a:r>
+              <a:t>▪ Dotación de equipos de computación dedicados para operadores de consola.</a:t>
             </a:r>
           </a:p>
           <a:p>
@@ -9472,15 +9474,15 @@
               <a:spcAft>
                 <a:spcPts val="800"/>
               </a:spcAft>
-              <a:defRPr sz="1200">
-                <a:solidFill>
-                  <a:srgbClr val="94A3B8"/>
-                </a:solidFill>
-                <a:latin typeface="Arial"/>
-              </a:defRPr>
-            </a:pPr>
-            <a:r>
-              <a:t>• Pantallas de visualización simultánea de los 5 módulos.</a:t>
+              <a:defRPr sz="1150">
+                <a:solidFill>
+                  <a:srgbClr val="64748B"/>
+                </a:solidFill>
+                <a:latin typeface="Arial"/>
+              </a:defRPr>
+            </a:pPr>
+            <a:r>
+              <a:t>▪ Instalación de pantallas de visualización general para seguimiento en tiempo real.</a:t>
             </a:r>
           </a:p>
           <a:p>
@@ -9488,15 +9490,15 @@
               <a:spcAft>
                 <a:spcPts val="800"/>
               </a:spcAft>
-              <a:defRPr sz="1200">
-                <a:solidFill>
-                  <a:srgbClr val="94A3B8"/>
-                </a:solidFill>
-                <a:latin typeface="Arial"/>
-              </a:defRPr>
-            </a:pPr>
-            <a:r>
-              <a:t>• Sistemas de respaldo eléctrico (inversores / UPS) para operar durante las fallas del servicio eléctrico.</a:t>
+              <a:defRPr sz="1150">
+                <a:solidFill>
+                  <a:srgbClr val="64748B"/>
+                </a:solidFill>
+                <a:latin typeface="Arial"/>
+              </a:defRPr>
+            </a:pPr>
+            <a:r>
+              <a:t>▪ Sistemas de respaldo eléctrico (inversores / UPS) para garantizar continuidad operativa ante fallas del servicio eléctrico regional.</a:t>
             </a:r>
           </a:p>
         </p:txBody>

</xml_diff>